<commit_message>
Publication-rigor upgrade part 5: consolidate 30-repeat significance, CQR, MLP, and Dept B findings into full_project_results.pptx (21 slides); fix same multi-line table bug in this script too
</commit_message>
<xml_diff>
--- a/slides/full_project_results.pptx
+++ b/slides/full_project_results.pptx
@@ -21,6 +21,11 @@
     <p:sldId id="269" r:id="rId20"/>
     <p:sldId id="270" r:id="rId21"/>
     <p:sldId id="271" r:id="rId22"/>
+    <p:sldId id="272" r:id="rId23"/>
+    <p:sldId id="273" r:id="rId24"/>
+    <p:sldId id="274" r:id="rId25"/>
+    <p:sldId id="275" r:id="rId26"/>
+    <p:sldId id="276" r:id="rId27"/>
   </p:sldIdLst>
   <p:sldSz cx="12191695" cy="6858000" type="screen4x3"/>
   <p:notesSz cx="6858000" cy="9144000"/>
@@ -3268,7 +3273,7 @@
                 </a:solidFill>
                 <a:latin typeface="Calibri"/>
               </a:rPr>
-              <a:t>Full Project Results (through Week 15)</a:t>
+              <a:t>Full Project Results + Publication-Rigor Upgrade</a:t>
             </a:r>
           </a:p>
         </p:txBody>
@@ -3549,7 +3554,7 @@
                 </a:solidFill>
                 <a:latin typeface="Calibri"/>
               </a:rPr>
-              <a:t>10 / 16</a:t>
+              <a:t>10 / 21</a:t>
             </a:r>
           </a:p>
         </p:txBody>
@@ -4430,7 +4435,7 @@
                 </a:solidFill>
                 <a:latin typeface="Calibri"/>
               </a:rPr>
-              <a:t>11 / 16</a:t>
+              <a:t>11 / 21</a:t>
             </a:r>
           </a:p>
         </p:txBody>
@@ -4498,7 +4503,13 @@
                       </a:r>
                     </a:p>
                     <a:p>
-                      <a:r>
+                      <a:pPr algn="ctr"/>
+                      <a:r>
+                        <a:rPr sz="1300" b="1">
+                          <a:solidFill>
+                            <a:srgbClr val="FFFFFF"/>
+                          </a:solidFill>
+                        </a:rPr>
                         <a:t>(staff=Low / arrival=High)</a:t>
                       </a:r>
                     </a:p>
@@ -4525,7 +4536,13 @@
                       </a:r>
                     </a:p>
                     <a:p>
-                      <a:r>
+                      <a:pPr algn="ctr"/>
+                      <a:r>
+                        <a:rPr sz="1300" b="1">
+                          <a:solidFill>
+                            <a:srgbClr val="FFFFFF"/>
+                          </a:solidFill>
+                        </a:rPr>
                         <a:t>(same category)</a:t>
                       </a:r>
                     </a:p>
@@ -5144,7 +5161,7 @@
                 </a:solidFill>
                 <a:latin typeface="Calibri"/>
               </a:rPr>
-              <a:t>12 / 16</a:t>
+              <a:t>12 / 21</a:t>
             </a:r>
           </a:p>
         </p:txBody>
@@ -5203,7 +5220,7 @@
                 </a:solidFill>
                 <a:latin typeface="Calibri"/>
               </a:rPr>
-              <a:t>CP calibrates ~650–1000x faster than GP (~0.01s vs. 7–11.5s). Mondrian CP's marginal coverage matches or beats standard CP's despite ~9x smaller per-category calibration slices, and is also usually narrower — pooling was wasting width in easy categories.</a:t>
+              <a:t>CP calibrates ~650–1000x faster than GP (~0.01s vs. 7–11.5s). Mondrian CP's marginal coverage matches or beats standard CP's despite ~9x smaller per-category calibration slices, and is also usually narrower — pooling was wasting width in easy categories. (Single-split result — see the 30-repeat validated version on the next slide.)</a:t>
             </a:r>
           </a:p>
         </p:txBody>
@@ -5300,7 +5317,7 @@
                 </a:solidFill>
                 <a:latin typeface="Calibri"/>
               </a:rPr>
-              <a:t>RESULTS</a:t>
+              <a:t>RESULTS — VALIDATED</a:t>
             </a:r>
           </a:p>
         </p:txBody>
@@ -5329,13 +5346,13 @@
           <a:p>
             <a:pPr algn="l"/>
             <a:r>
-              <a:rPr sz="2600" b="1" i="0">
+              <a:rPr sz="2400" b="1" i="0">
                 <a:solidFill>
                   <a:srgbClr val="1B2238"/>
                 </a:solidFill>
                 <a:latin typeface="Calibri"/>
               </a:rPr>
-              <a:t>Exchangeability Stress Test</a:t>
+              <a:t>All 5 Methods, 30 Independent Repeats</a:t>
             </a:r>
           </a:p>
         </p:txBody>
@@ -5414,7 +5431,277 @@
                 </a:solidFill>
                 <a:latin typeface="Calibri"/>
               </a:rPr>
-              <a:t>13 / 16</a:t>
+              <a:t>13 / 21</a:t>
+            </a:r>
+          </a:p>
+        </p:txBody>
+      </p:sp>
+      <p:pic>
+        <p:nvPicPr>
+          <p:cNvPr id="7" name="Picture 6" descr="publication_comparison.png"/>
+          <p:cNvPicPr>
+            <a:picLocks noChangeAspect="1"/>
+          </p:cNvPicPr>
+          <p:nvPr/>
+        </p:nvPicPr>
+        <p:blipFill>
+          <a:blip r:embed="rId2"/>
+          <a:stretch>
+            <a:fillRect/>
+          </a:stretch>
+        </p:blipFill>
+        <p:spPr>
+          <a:xfrm>
+            <a:off x="640080" y="1371600"/>
+            <a:ext cx="10881360" cy="4185138"/>
+          </a:xfrm>
+          <a:prstGeom prst="rect">
+            <a:avLst/>
+          </a:prstGeom>
+        </p:spPr>
+      </p:pic>
+      <p:sp>
+        <p:nvSpPr>
+          <p:cNvPr id="8" name="TextBox 7"/>
+          <p:cNvSpPr txBox="1"/>
+          <p:nvPr/>
+        </p:nvSpPr>
+        <p:spPr>
+          <a:xfrm>
+            <a:off x="640080" y="6035040"/>
+            <a:ext cx="10881360" cy="731520"/>
+          </a:xfrm>
+          <a:prstGeom prst="rect">
+            <a:avLst/>
+          </a:prstGeom>
+          <a:noFill/>
+        </p:spPr>
+        <p:txBody>
+          <a:bodyPr wrap="square" anchor="t" lIns="0" rIns="0" tIns="0" bIns="0">
+            <a:spAutoFit/>
+          </a:bodyPr>
+          <a:lstStyle/>
+          <a:p>
+            <a:pPr algn="l"/>
+            <a:r>
+              <a:rPr sz="1300" b="0" i="1">
+                <a:solidFill>
+                  <a:srgbClr val="6B7280"/>
+                </a:solidFill>
+                <a:latin typeface="Calibri"/>
+              </a:rPr>
+              <a:t>Error bars are 95% CI on the mean across 30 independent calibration/test draws — tight enough to read as single dots, meaning these differences are stable, not single-split noise. CQR (adaptive, quantile-regression-based) joins the comparison as a fifth method.</a:t>
+            </a:r>
+          </a:p>
+        </p:txBody>
+      </p:sp>
+    </p:spTree>
+  </p:cSld>
+  <p:clrMapOvr>
+    <a:masterClrMapping/>
+  </p:clrMapOvr>
+</p:sld>
+</file>
+
+<file path=ppt/slides/slide14.xml><?xml version="1.0" encoding="utf-8"?>
+<p:sld xmlns:a="http://schemas.openxmlformats.org/drawingml/2006/main" xmlns:p="http://schemas.openxmlformats.org/presentationml/2006/main" xmlns:r="http://schemas.openxmlformats.org/officeDocument/2006/relationships">
+  <p:cSld>
+    <p:spTree>
+      <p:nvGrpSpPr>
+        <p:cNvPr id="1" name=""/>
+        <p:cNvGrpSpPr/>
+        <p:nvPr/>
+      </p:nvGrpSpPr>
+      <p:grpSpPr/>
+      <p:sp>
+        <p:nvSpPr>
+          <p:cNvPr id="2" name="Rectangle 1"/>
+          <p:cNvSpPr/>
+          <p:nvPr/>
+        </p:nvSpPr>
+        <p:spPr>
+          <a:xfrm>
+            <a:off x="0" y="0"/>
+            <a:ext cx="12191695" cy="82296"/>
+          </a:xfrm>
+          <a:prstGeom prst="rect">
+            <a:avLst/>
+          </a:prstGeom>
+          <a:solidFill>
+            <a:srgbClr val="3B82F6"/>
+          </a:solidFill>
+          <a:ln>
+            <a:noFill/>
+          </a:ln>
+          <a:effectLst/>
+        </p:spPr>
+        <p:style>
+          <a:lnRef idx="1">
+            <a:schemeClr val="accent1"/>
+          </a:lnRef>
+          <a:fillRef idx="3">
+            <a:schemeClr val="accent1"/>
+          </a:fillRef>
+          <a:effectRef idx="2">
+            <a:schemeClr val="accent1"/>
+          </a:effectRef>
+          <a:fontRef idx="minor">
+            <a:schemeClr val="lt1"/>
+          </a:fontRef>
+        </p:style>
+        <p:txBody>
+          <a:bodyPr rtlCol="0" anchor="ctr"/>
+          <a:lstStyle/>
+          <a:p>
+            <a:pPr algn="ctr"/>
+          </a:p>
+        </p:txBody>
+      </p:sp>
+      <p:sp>
+        <p:nvSpPr>
+          <p:cNvPr id="3" name="TextBox 2"/>
+          <p:cNvSpPr txBox="1"/>
+          <p:nvPr/>
+        </p:nvSpPr>
+        <p:spPr>
+          <a:xfrm>
+            <a:off x="548640" y="274320"/>
+            <a:ext cx="10515600" cy="320040"/>
+          </a:xfrm>
+          <a:prstGeom prst="rect">
+            <a:avLst/>
+          </a:prstGeom>
+          <a:noFill/>
+        </p:spPr>
+        <p:txBody>
+          <a:bodyPr wrap="square" anchor="t" lIns="0" rIns="0" tIns="0" bIns="0">
+            <a:spAutoFit/>
+          </a:bodyPr>
+          <a:lstStyle/>
+          <a:p>
+            <a:pPr algn="l"/>
+            <a:r>
+              <a:rPr sz="1300" b="1" i="0">
+                <a:solidFill>
+                  <a:srgbClr val="3B82F6"/>
+                </a:solidFill>
+                <a:latin typeface="Calibri"/>
+              </a:rPr>
+              <a:t>RESULTS</a:t>
+            </a:r>
+          </a:p>
+        </p:txBody>
+      </p:sp>
+      <p:sp>
+        <p:nvSpPr>
+          <p:cNvPr id="4" name="TextBox 3"/>
+          <p:cNvSpPr txBox="1"/>
+          <p:nvPr/>
+        </p:nvSpPr>
+        <p:spPr>
+          <a:xfrm>
+            <a:off x="548640" y="566928"/>
+            <a:ext cx="10881360" cy="640080"/>
+          </a:xfrm>
+          <a:prstGeom prst="rect">
+            <a:avLst/>
+          </a:prstGeom>
+          <a:noFill/>
+        </p:spPr>
+        <p:txBody>
+          <a:bodyPr wrap="square" anchor="t" lIns="0" rIns="0" tIns="0" bIns="0">
+            <a:spAutoFit/>
+          </a:bodyPr>
+          <a:lstStyle/>
+          <a:p>
+            <a:pPr algn="l"/>
+            <a:r>
+              <a:rPr sz="2600" b="1" i="0">
+                <a:solidFill>
+                  <a:srgbClr val="1B2238"/>
+                </a:solidFill>
+                <a:latin typeface="Calibri"/>
+              </a:rPr>
+              <a:t>Exchangeability Stress Test</a:t>
+            </a:r>
+          </a:p>
+        </p:txBody>
+      </p:sp>
+      <p:sp>
+        <p:nvSpPr>
+          <p:cNvPr id="5" name="Rectangle 4"/>
+          <p:cNvSpPr/>
+          <p:nvPr/>
+        </p:nvSpPr>
+        <p:spPr>
+          <a:xfrm>
+            <a:off x="548640" y="1170432"/>
+            <a:ext cx="1005840" cy="38100"/>
+          </a:xfrm>
+          <a:prstGeom prst="rect">
+            <a:avLst/>
+          </a:prstGeom>
+          <a:solidFill>
+            <a:srgbClr val="3B82F6"/>
+          </a:solidFill>
+          <a:ln>
+            <a:noFill/>
+          </a:ln>
+          <a:effectLst/>
+        </p:spPr>
+        <p:style>
+          <a:lnRef idx="1">
+            <a:schemeClr val="accent1"/>
+          </a:lnRef>
+          <a:fillRef idx="3">
+            <a:schemeClr val="accent1"/>
+          </a:fillRef>
+          <a:effectRef idx="2">
+            <a:schemeClr val="accent1"/>
+          </a:effectRef>
+          <a:fontRef idx="minor">
+            <a:schemeClr val="lt1"/>
+          </a:fontRef>
+        </p:style>
+        <p:txBody>
+          <a:bodyPr rtlCol="0" anchor="ctr"/>
+          <a:lstStyle/>
+          <a:p>
+            <a:pPr algn="ctr"/>
+          </a:p>
+        </p:txBody>
+      </p:sp>
+      <p:sp>
+        <p:nvSpPr>
+          <p:cNvPr id="6" name="TextBox 5"/>
+          <p:cNvSpPr txBox="1"/>
+          <p:nvPr/>
+        </p:nvSpPr>
+        <p:spPr>
+          <a:xfrm>
+            <a:off x="11155680" y="6446520"/>
+            <a:ext cx="822960" cy="320040"/>
+          </a:xfrm>
+          <a:prstGeom prst="rect">
+            <a:avLst/>
+          </a:prstGeom>
+          <a:noFill/>
+        </p:spPr>
+        <p:txBody>
+          <a:bodyPr wrap="square" anchor="t" lIns="0" rIns="0" tIns="0" bIns="0">
+            <a:spAutoFit/>
+          </a:bodyPr>
+          <a:lstStyle/>
+          <a:p>
+            <a:pPr algn="r"/>
+            <a:r>
+              <a:rPr sz="1100" b="0" i="0">
+                <a:solidFill>
+                  <a:srgbClr val="6B7280"/>
+                </a:solidFill>
+                <a:latin typeface="Calibri"/>
+              </a:rPr>
+              <a:t>14 / 21</a:t>
             </a:r>
           </a:p>
         </p:txBody>
@@ -6257,336 +6544,6 @@
 </p:sld>
 </file>
 
-<file path=ppt/slides/slide14.xml><?xml version="1.0" encoding="utf-8"?>
-<p:sld xmlns:a="http://schemas.openxmlformats.org/drawingml/2006/main" xmlns:p="http://schemas.openxmlformats.org/presentationml/2006/main" xmlns:r="http://schemas.openxmlformats.org/officeDocument/2006/relationships">
-  <p:cSld>
-    <p:spTree>
-      <p:nvGrpSpPr>
-        <p:cNvPr id="1" name=""/>
-        <p:cNvGrpSpPr/>
-        <p:nvPr/>
-      </p:nvGrpSpPr>
-      <p:grpSpPr/>
-      <p:sp>
-        <p:nvSpPr>
-          <p:cNvPr id="2" name="Rectangle 1"/>
-          <p:cNvSpPr/>
-          <p:nvPr/>
-        </p:nvSpPr>
-        <p:spPr>
-          <a:xfrm>
-            <a:off x="0" y="0"/>
-            <a:ext cx="12191695" cy="82296"/>
-          </a:xfrm>
-          <a:prstGeom prst="rect">
-            <a:avLst/>
-          </a:prstGeom>
-          <a:solidFill>
-            <a:srgbClr val="3B82F6"/>
-          </a:solidFill>
-          <a:ln>
-            <a:noFill/>
-          </a:ln>
-          <a:effectLst/>
-        </p:spPr>
-        <p:style>
-          <a:lnRef idx="1">
-            <a:schemeClr val="accent1"/>
-          </a:lnRef>
-          <a:fillRef idx="3">
-            <a:schemeClr val="accent1"/>
-          </a:fillRef>
-          <a:effectRef idx="2">
-            <a:schemeClr val="accent1"/>
-          </a:effectRef>
-          <a:fontRef idx="minor">
-            <a:schemeClr val="lt1"/>
-          </a:fontRef>
-        </p:style>
-        <p:txBody>
-          <a:bodyPr rtlCol="0" anchor="ctr"/>
-          <a:lstStyle/>
-          <a:p>
-            <a:pPr algn="ctr"/>
-          </a:p>
-        </p:txBody>
-      </p:sp>
-      <p:sp>
-        <p:nvSpPr>
-          <p:cNvPr id="3" name="TextBox 2"/>
-          <p:cNvSpPr txBox="1"/>
-          <p:nvPr/>
-        </p:nvSpPr>
-        <p:spPr>
-          <a:xfrm>
-            <a:off x="548640" y="274320"/>
-            <a:ext cx="10515600" cy="320040"/>
-          </a:xfrm>
-          <a:prstGeom prst="rect">
-            <a:avLst/>
-          </a:prstGeom>
-          <a:noFill/>
-        </p:spPr>
-        <p:txBody>
-          <a:bodyPr wrap="square" anchor="t" lIns="0" rIns="0" tIns="0" bIns="0">
-            <a:spAutoFit/>
-          </a:bodyPr>
-          <a:lstStyle/>
-          <a:p>
-            <a:pPr algn="l"/>
-            <a:r>
-              <a:rPr sz="1300" b="1" i="0">
-                <a:solidFill>
-                  <a:srgbClr val="3B82F6"/>
-                </a:solidFill>
-                <a:latin typeface="Calibri"/>
-              </a:rPr>
-              <a:t>SUMMARY</a:t>
-            </a:r>
-          </a:p>
-        </p:txBody>
-      </p:sp>
-      <p:sp>
-        <p:nvSpPr>
-          <p:cNvPr id="4" name="TextBox 3"/>
-          <p:cNvSpPr txBox="1"/>
-          <p:nvPr/>
-        </p:nvSpPr>
-        <p:spPr>
-          <a:xfrm>
-            <a:off x="548640" y="566928"/>
-            <a:ext cx="10881360" cy="640080"/>
-          </a:xfrm>
-          <a:prstGeom prst="rect">
-            <a:avLst/>
-          </a:prstGeom>
-          <a:noFill/>
-        </p:spPr>
-        <p:txBody>
-          <a:bodyPr wrap="square" anchor="t" lIns="0" rIns="0" tIns="0" bIns="0">
-            <a:spAutoFit/>
-          </a:bodyPr>
-          <a:lstStyle/>
-          <a:p>
-            <a:pPr algn="l"/>
-            <a:r>
-              <a:rPr sz="2600" b="1" i="0">
-                <a:solidFill>
-                  <a:srgbClr val="1B2238"/>
-                </a:solidFill>
-                <a:latin typeface="Calibri"/>
-              </a:rPr>
-              <a:t>What We Accomplished</a:t>
-            </a:r>
-          </a:p>
-        </p:txBody>
-      </p:sp>
-      <p:sp>
-        <p:nvSpPr>
-          <p:cNvPr id="5" name="Rectangle 4"/>
-          <p:cNvSpPr/>
-          <p:nvPr/>
-        </p:nvSpPr>
-        <p:spPr>
-          <a:xfrm>
-            <a:off x="548640" y="1170432"/>
-            <a:ext cx="1005840" cy="38100"/>
-          </a:xfrm>
-          <a:prstGeom prst="rect">
-            <a:avLst/>
-          </a:prstGeom>
-          <a:solidFill>
-            <a:srgbClr val="3B82F6"/>
-          </a:solidFill>
-          <a:ln>
-            <a:noFill/>
-          </a:ln>
-          <a:effectLst/>
-        </p:spPr>
-        <p:style>
-          <a:lnRef idx="1">
-            <a:schemeClr val="accent1"/>
-          </a:lnRef>
-          <a:fillRef idx="3">
-            <a:schemeClr val="accent1"/>
-          </a:fillRef>
-          <a:effectRef idx="2">
-            <a:schemeClr val="accent1"/>
-          </a:effectRef>
-          <a:fontRef idx="minor">
-            <a:schemeClr val="lt1"/>
-          </a:fontRef>
-        </p:style>
-        <p:txBody>
-          <a:bodyPr rtlCol="0" anchor="ctr"/>
-          <a:lstStyle/>
-          <a:p>
-            <a:pPr algn="ctr"/>
-          </a:p>
-        </p:txBody>
-      </p:sp>
-      <p:sp>
-        <p:nvSpPr>
-          <p:cNvPr id="6" name="TextBox 5"/>
-          <p:cNvSpPr txBox="1"/>
-          <p:nvPr/>
-        </p:nvSpPr>
-        <p:spPr>
-          <a:xfrm>
-            <a:off x="11155680" y="6446520"/>
-            <a:ext cx="822960" cy="320040"/>
-          </a:xfrm>
-          <a:prstGeom prst="rect">
-            <a:avLst/>
-          </a:prstGeom>
-          <a:noFill/>
-        </p:spPr>
-        <p:txBody>
-          <a:bodyPr wrap="square" anchor="t" lIns="0" rIns="0" tIns="0" bIns="0">
-            <a:spAutoFit/>
-          </a:bodyPr>
-          <a:lstStyle/>
-          <a:p>
-            <a:pPr algn="r"/>
-            <a:r>
-              <a:rPr sz="1100" b="0" i="0">
-                <a:solidFill>
-                  <a:srgbClr val="6B7280"/>
-                </a:solidFill>
-                <a:latin typeface="Calibri"/>
-              </a:rPr>
-              <a:t>14 / 16</a:t>
-            </a:r>
-          </a:p>
-        </p:txBody>
-      </p:sp>
-      <p:sp>
-        <p:nvSpPr>
-          <p:cNvPr id="7" name="TextBox 6"/>
-          <p:cNvSpPr txBox="1"/>
-          <p:nvPr/>
-        </p:nvSpPr>
-        <p:spPr>
-          <a:xfrm>
-            <a:off x="640080" y="1600200"/>
-            <a:ext cx="10881360" cy="4572000"/>
-          </a:xfrm>
-          <a:prstGeom prst="rect">
-            <a:avLst/>
-          </a:prstGeom>
-          <a:noFill/>
-        </p:spPr>
-        <p:txBody>
-          <a:bodyPr wrap="square">
-            <a:spAutoFit/>
-          </a:bodyPr>
-          <a:lstStyle/>
-          <a:p>
-            <a:pPr>
-              <a:spcAft>
-                <a:spcPts val="1300"/>
-              </a:spcAft>
-            </a:pPr>
-            <a:r>
-              <a:rPr sz="1600">
-                <a:solidFill>
-                  <a:srgbClr val="1F2937"/>
-                </a:solidFill>
-                <a:latin typeface="Calibri"/>
-              </a:rPr>
-              <a:t>•  Built and validated an ER discrete-event simulation (SimPy) calibrated on real hospital arrival data — 91.0% match to real daily patient volume.</a:t>
-            </a:r>
-          </a:p>
-          <a:p>
-            <a:pPr>
-              <a:spcAft>
-                <a:spcPts val="1300"/>
-              </a:spcAft>
-            </a:pPr>
-            <a:r>
-              <a:rPr sz="1600">
-                <a:solidFill>
-                  <a:srgbClr val="1F2937"/>
-                </a:solidFill>
-                <a:latin typeface="Calibri"/>
-              </a:rPr>
-              <a:t>•  Generated a 5000-scenario training sweep and trained a surrogate model with strong accuracy on 3 of 4 targets (R² 0.76–0.93).</a:t>
-            </a:r>
-          </a:p>
-          <a:p>
-            <a:pPr>
-              <a:spcAft>
-                <a:spcPts val="1300"/>
-              </a:spcAft>
-            </a:pPr>
-            <a:r>
-              <a:rPr sz="1600">
-                <a:solidFill>
-                  <a:srgbClr val="1F2937"/>
-                </a:solidFill>
-                <a:latin typeface="Calibri"/>
-              </a:rPr>
-              <a:t>•  Implemented a GP baseline, standard conformal prediction (two nonconformity measures), and Mondrian conformal prediction, all evaluated on the same test split and target coverage.</a:t>
-            </a:r>
-          </a:p>
-          <a:p>
-            <a:pPr>
-              <a:spcAft>
-                <a:spcPts val="1300"/>
-              </a:spcAft>
-            </a:pPr>
-            <a:r>
-              <a:rPr sz="1600">
-                <a:solidFill>
-                  <a:srgbClr val="1F2937"/>
-                </a:solidFill>
-                <a:latin typeface="Calibri"/>
-              </a:rPr>
-              <a:t>•  Demonstrated Mondrian CP closing a real marginal-vs-conditional coverage gap (68–81% pooled coverage in the hardest category, corrected to 91–92%), and quantified where it doesn't help.</a:t>
-            </a:r>
-          </a:p>
-          <a:p>
-            <a:pPr>
-              <a:spcAft>
-                <a:spcPts val="1300"/>
-              </a:spcAft>
-            </a:pPr>
-            <a:r>
-              <a:rPr sz="1600">
-                <a:solidFill>
-                  <a:srgbClr val="1F2937"/>
-                </a:solidFill>
-                <a:latin typeface="Calibri"/>
-              </a:rPr>
-              <a:t>•  Ran an exchangeability stress test across 8 severity levels and root-caused the coverage collapse to a specific, verified mechanism, not just "it broke."</a:t>
-            </a:r>
-          </a:p>
-          <a:p>
-            <a:pPr>
-              <a:spcAft>
-                <a:spcPts val="1300"/>
-              </a:spcAft>
-            </a:pPr>
-            <a:r>
-              <a:rPr sz="1600">
-                <a:solidFill>
-                  <a:srgbClr val="1F2937"/>
-                </a:solidFill>
-                <a:latin typeface="Calibri"/>
-              </a:rPr>
-              <a:t>•  Full head-to-head comparison of all three UQ methods on coverage, interval width, and computation time.</a:t>
-            </a:r>
-          </a:p>
-        </p:txBody>
-      </p:sp>
-    </p:spTree>
-  </p:cSld>
-  <p:clrMapOvr>
-    <a:masterClrMapping/>
-  </p:clrMapOvr>
-</p:sld>
-</file>
-
 <file path=ppt/slides/slide15.xml><?xml version="1.0" encoding="utf-8"?>
 <p:sld xmlns:a="http://schemas.openxmlformats.org/drawingml/2006/main" xmlns:p="http://schemas.openxmlformats.org/presentationml/2006/main" xmlns:r="http://schemas.openxmlformats.org/officeDocument/2006/relationships">
   <p:cSld>
@@ -6671,7 +6628,7 @@
                 </a:solidFill>
                 <a:latin typeface="Calibri"/>
               </a:rPr>
-              <a:t>VERDICT</a:t>
+              <a:t>PUBLICATION-RIGOR UPGRADE</a:t>
             </a:r>
           </a:p>
         </p:txBody>
@@ -6700,13 +6657,13 @@
           <a:p>
             <a:pPr algn="l"/>
             <a:r>
-              <a:rPr sz="2400" b="1" i="0">
+              <a:rPr sz="2200" b="1" i="0">
                 <a:solidFill>
                   <a:srgbClr val="1B2238"/>
                 </a:solidFill>
                 <a:latin typeface="Calibri"/>
               </a:rPr>
-              <a:t>Did We Meet Our Novelty Target?</a:t>
+              <a:t>Statistical Rigor: 30 Independent Repeats</a:t>
             </a:r>
           </a:p>
         </p:txBody>
@@ -6785,7 +6742,7 @@
                 </a:solidFill>
                 <a:latin typeface="Calibri"/>
               </a:rPr>
-              <a:t>15 / 16</a:t>
+              <a:t>15 / 21</a:t>
             </a:r>
           </a:p>
         </p:txBody>
@@ -6798,8 +6755,8 @@
         </p:nvSpPr>
         <p:spPr>
           <a:xfrm>
-            <a:off x="640080" y="1554480"/>
-            <a:ext cx="10881360" cy="1005840"/>
+            <a:off x="640080" y="1463040"/>
+            <a:ext cx="10881360" cy="822960"/>
           </a:xfrm>
           <a:prstGeom prst="rect">
             <a:avLst/>
@@ -6814,27 +6771,685 @@
           <a:p>
             <a:pPr algn="l"/>
             <a:r>
-              <a:rPr sz="1600" b="0" i="0">
+              <a:rPr sz="1500" b="0" i="0">
                 <a:solidFill>
                   <a:srgbClr val="1F2937"/>
                 </a:solidFill>
                 <a:latin typeface="Calibri"/>
               </a:rPr>
-              <a:t>The claim was to test Gopakumar et al. (2026)'s two stated CP limitations — marginal coverage, exchangeability — outside the physics domains they validated CP in, using a discrete-event / queueing simulation surrogate instead.</a:t>
-            </a:r>
-          </a:p>
-        </p:txBody>
-      </p:sp>
-      <p:sp>
-        <p:nvSpPr>
-          <p:cNvPr id="8" name="Rectangle 7"/>
+              <a:t>Every result so far was a single train/test split — no way to tell if a number like "68.2% coverage" was a robust effect or one unlucky draw. Repeated the full GP / standard-CP / Mondrian-CP pipeline across 30 independent (calibration, test) draws.</a:t>
+            </a:r>
+          </a:p>
+        </p:txBody>
+      </p:sp>
+      <p:graphicFrame>
+        <p:nvGraphicFramePr>
+          <p:cNvPr id="8" name="Table 7"/>
+          <p:cNvGraphicFramePr>
+            <a:graphicFrameLocks noGrp="1"/>
+          </p:cNvGraphicFramePr>
+          <p:nvPr/>
+        </p:nvGraphicFramePr>
+        <p:xfrm>
+          <a:off x="640080" y="2423160"/>
+          <a:ext cx="10881360" cy="2194560"/>
+        </p:xfrm>
+        <a:graphic>
+          <a:graphicData uri="http://schemas.openxmlformats.org/drawingml/2006/table">
+            <a:tbl>
+              <a:tblPr firstRow="1" bandRow="1">
+                <a:tableStyleId>{5C22544A-7EE6-4342-B048-85BDC9FD1C3A}</a:tableStyleId>
+              </a:tblPr>
+              <a:tblGrid>
+                <a:gridCol w="2651760"/>
+                <a:gridCol w="2194560"/>
+                <a:gridCol w="3108960"/>
+                <a:gridCol w="2926080"/>
+              </a:tblGrid>
+              <a:tr h="313508">
+                <a:tc>
+                  <a:txBody>
+                    <a:bodyPr/>
+                    <a:lstStyle/>
+                    <a:p>
+                      <a:pPr algn="l"/>
+                      <a:r>
+                        <a:rPr sz="1200" b="1">
+                          <a:solidFill>
+                            <a:srgbClr val="FFFFFF"/>
+                          </a:solidFill>
+                        </a:rPr>
+                        <a:t>Target</a:t>
+                      </a:r>
+                    </a:p>
+                  </a:txBody>
+                  <a:tcPr anchor="ctr" marT="50800" marB="50800">
+                    <a:solidFill>
+                      <a:srgbClr val="1E40AF"/>
+                    </a:solidFill>
+                  </a:tcPr>
+                </a:tc>
+                <a:tc>
+                  <a:txBody>
+                    <a:bodyPr/>
+                    <a:lstStyle/>
+                    <a:p>
+                      <a:pPr algn="ctr"/>
+                      <a:r>
+                        <a:rPr sz="1200" b="1">
+                          <a:solidFill>
+                            <a:srgbClr val="FFFFFF"/>
+                          </a:solidFill>
+                        </a:rPr>
+                        <a:t>Method</a:t>
+                      </a:r>
+                    </a:p>
+                  </a:txBody>
+                  <a:tcPr anchor="ctr" marT="50800" marB="50800">
+                    <a:solidFill>
+                      <a:srgbClr val="1E40AF"/>
+                    </a:solidFill>
+                  </a:tcPr>
+                </a:tc>
+                <a:tc>
+                  <a:txBody>
+                    <a:bodyPr/>
+                    <a:lstStyle/>
+                    <a:p>
+                      <a:pPr algn="ctr"/>
+                      <a:r>
+                        <a:rPr sz="1200" b="1">
+                          <a:solidFill>
+                            <a:srgbClr val="FFFFFF"/>
+                          </a:solidFill>
+                        </a:rPr>
+                        <a:t>Coverage (mean ± 95% CI)</a:t>
+                      </a:r>
+                    </a:p>
+                  </a:txBody>
+                  <a:tcPr anchor="ctr" marT="50800" marB="50800">
+                    <a:solidFill>
+                      <a:srgbClr val="1E40AF"/>
+                    </a:solidFill>
+                  </a:tcPr>
+                </a:tc>
+                <a:tc>
+                  <a:txBody>
+                    <a:bodyPr/>
+                    <a:lstStyle/>
+                    <a:p>
+                      <a:pPr algn="ctr"/>
+                      <a:r>
+                        <a:rPr sz="1200" b="1">
+                          <a:solidFill>
+                            <a:srgbClr val="FFFFFF"/>
+                          </a:solidFill>
+                        </a:rPr>
+                        <a:t>Width (mean ± 95% CI)</a:t>
+                      </a:r>
+                    </a:p>
+                  </a:txBody>
+                  <a:tcPr anchor="ctr" marT="50800" marB="50800">
+                    <a:solidFill>
+                      <a:srgbClr val="1E40AF"/>
+                    </a:solidFill>
+                  </a:tcPr>
+                </a:tc>
+              </a:tr>
+              <a:tr h="313508">
+                <a:tc>
+                  <a:txBody>
+                    <a:bodyPr/>
+                    <a:lstStyle/>
+                    <a:p>
+                      <a:pPr algn="l"/>
+                      <a:r>
+                        <a:rPr sz="1200">
+                          <a:solidFill>
+                            <a:srgbClr val="1F2937"/>
+                          </a:solidFill>
+                        </a:rPr>
+                        <a:t>mean_wait_minutes</a:t>
+                      </a:r>
+                    </a:p>
+                  </a:txBody>
+                  <a:tcPr anchor="ctr" marT="50800" marB="50800">
+                    <a:solidFill>
+                      <a:srgbClr val="F8FAFC"/>
+                    </a:solidFill>
+                  </a:tcPr>
+                </a:tc>
+                <a:tc>
+                  <a:txBody>
+                    <a:bodyPr/>
+                    <a:lstStyle/>
+                    <a:p>
+                      <a:pPr algn="ctr"/>
+                      <a:r>
+                        <a:rPr sz="1200">
+                          <a:solidFill>
+                            <a:srgbClr val="1F2937"/>
+                          </a:solidFill>
+                        </a:rPr>
+                        <a:t>GP</a:t>
+                      </a:r>
+                    </a:p>
+                  </a:txBody>
+                  <a:tcPr anchor="ctr" marT="50800" marB="50800">
+                    <a:solidFill>
+                      <a:srgbClr val="F8FAFC"/>
+                    </a:solidFill>
+                  </a:tcPr>
+                </a:tc>
+                <a:tc>
+                  <a:txBody>
+                    <a:bodyPr/>
+                    <a:lstStyle/>
+                    <a:p>
+                      <a:pPr algn="ctr"/>
+                      <a:r>
+                        <a:rPr sz="1200">
+                          <a:solidFill>
+                            <a:srgbClr val="1F2937"/>
+                          </a:solidFill>
+                        </a:rPr>
+                        <a:t>88.31% ± 0.47%</a:t>
+                      </a:r>
+                    </a:p>
+                  </a:txBody>
+                  <a:tcPr anchor="ctr" marT="50800" marB="50800">
+                    <a:solidFill>
+                      <a:srgbClr val="F8FAFC"/>
+                    </a:solidFill>
+                  </a:tcPr>
+                </a:tc>
+                <a:tc>
+                  <a:txBody>
+                    <a:bodyPr/>
+                    <a:lstStyle/>
+                    <a:p>
+                      <a:pPr algn="ctr"/>
+                      <a:r>
+                        <a:rPr sz="1200">
+                          <a:solidFill>
+                            <a:srgbClr val="1F2937"/>
+                          </a:solidFill>
+                        </a:rPr>
+                        <a:t>44.4 ± 1.1</a:t>
+                      </a:r>
+                    </a:p>
+                  </a:txBody>
+                  <a:tcPr anchor="ctr" marT="50800" marB="50800">
+                    <a:solidFill>
+                      <a:srgbClr val="F8FAFC"/>
+                    </a:solidFill>
+                  </a:tcPr>
+                </a:tc>
+              </a:tr>
+              <a:tr h="313508">
+                <a:tc>
+                  <a:txBody>
+                    <a:bodyPr/>
+                    <a:lstStyle/>
+                    <a:p>
+                      <a:pPr algn="l"/>
+                      <a:r>
+                        <a:rPr sz="1200">
+                          <a:solidFill>
+                            <a:srgbClr val="1F2937"/>
+                          </a:solidFill>
+                        </a:rPr>
+                        <a:t>mean_wait_minutes</a:t>
+                      </a:r>
+                    </a:p>
+                  </a:txBody>
+                  <a:tcPr anchor="ctr" marT="50800" marB="50800">
+                    <a:solidFill>
+                      <a:srgbClr val="FFFFFF"/>
+                    </a:solidFill>
+                  </a:tcPr>
+                </a:tc>
+                <a:tc>
+                  <a:txBody>
+                    <a:bodyPr/>
+                    <a:lstStyle/>
+                    <a:p>
+                      <a:pPr algn="ctr"/>
+                      <a:r>
+                        <a:rPr sz="1200">
+                          <a:solidFill>
+                            <a:srgbClr val="1F2937"/>
+                          </a:solidFill>
+                        </a:rPr>
+                        <a:t>Standard CP</a:t>
+                      </a:r>
+                    </a:p>
+                  </a:txBody>
+                  <a:tcPr anchor="ctr" marT="50800" marB="50800">
+                    <a:solidFill>
+                      <a:srgbClr val="FFFFFF"/>
+                    </a:solidFill>
+                  </a:tcPr>
+                </a:tc>
+                <a:tc>
+                  <a:txBody>
+                    <a:bodyPr/>
+                    <a:lstStyle/>
+                    <a:p>
+                      <a:pPr algn="ctr"/>
+                      <a:r>
+                        <a:rPr sz="1200">
+                          <a:solidFill>
+                            <a:srgbClr val="1F2937"/>
+                          </a:solidFill>
+                        </a:rPr>
+                        <a:t>90.09% ± 0.46%</a:t>
+                      </a:r>
+                    </a:p>
+                  </a:txBody>
+                  <a:tcPr anchor="ctr" marT="50800" marB="50800">
+                    <a:solidFill>
+                      <a:srgbClr val="FFFFFF"/>
+                    </a:solidFill>
+                  </a:tcPr>
+                </a:tc>
+                <a:tc>
+                  <a:txBody>
+                    <a:bodyPr/>
+                    <a:lstStyle/>
+                    <a:p>
+                      <a:pPr algn="ctr"/>
+                      <a:r>
+                        <a:rPr sz="1200">
+                          <a:solidFill>
+                            <a:srgbClr val="1F2937"/>
+                          </a:solidFill>
+                        </a:rPr>
+                        <a:t>48.0 ± 1.5</a:t>
+                      </a:r>
+                    </a:p>
+                  </a:txBody>
+                  <a:tcPr anchor="ctr" marT="50800" marB="50800">
+                    <a:solidFill>
+                      <a:srgbClr val="FFFFFF"/>
+                    </a:solidFill>
+                  </a:tcPr>
+                </a:tc>
+              </a:tr>
+              <a:tr h="313508">
+                <a:tc>
+                  <a:txBody>
+                    <a:bodyPr/>
+                    <a:lstStyle/>
+                    <a:p>
+                      <a:pPr algn="l"/>
+                      <a:r>
+                        <a:rPr sz="1200">
+                          <a:solidFill>
+                            <a:srgbClr val="1F2937"/>
+                          </a:solidFill>
+                        </a:rPr>
+                        <a:t>mean_wait_minutes</a:t>
+                      </a:r>
+                    </a:p>
+                  </a:txBody>
+                  <a:tcPr anchor="ctr" marT="50800" marB="50800">
+                    <a:solidFill>
+                      <a:srgbClr val="F8FAFC"/>
+                    </a:solidFill>
+                  </a:tcPr>
+                </a:tc>
+                <a:tc>
+                  <a:txBody>
+                    <a:bodyPr/>
+                    <a:lstStyle/>
+                    <a:p>
+                      <a:pPr algn="ctr"/>
+                      <a:r>
+                        <a:rPr sz="1200">
+                          <a:solidFill>
+                            <a:srgbClr val="1F2937"/>
+                          </a:solidFill>
+                        </a:rPr>
+                        <a:t>Mondrian CP</a:t>
+                      </a:r>
+                    </a:p>
+                  </a:txBody>
+                  <a:tcPr anchor="ctr" marT="50800" marB="50800">
+                    <a:solidFill>
+                      <a:srgbClr val="F8FAFC"/>
+                    </a:solidFill>
+                  </a:tcPr>
+                </a:tc>
+                <a:tc>
+                  <a:txBody>
+                    <a:bodyPr/>
+                    <a:lstStyle/>
+                    <a:p>
+                      <a:pPr algn="ctr"/>
+                      <a:r>
+                        <a:rPr sz="1200">
+                          <a:solidFill>
+                            <a:srgbClr val="1F2937"/>
+                          </a:solidFill>
+                        </a:rPr>
+                        <a:t>91.07% ± 0.35%</a:t>
+                      </a:r>
+                    </a:p>
+                  </a:txBody>
+                  <a:tcPr anchor="ctr" marT="50800" marB="50800">
+                    <a:solidFill>
+                      <a:srgbClr val="F8FAFC"/>
+                    </a:solidFill>
+                  </a:tcPr>
+                </a:tc>
+                <a:tc>
+                  <a:txBody>
+                    <a:bodyPr/>
+                    <a:lstStyle/>
+                    <a:p>
+                      <a:pPr algn="ctr"/>
+                      <a:r>
+                        <a:rPr sz="1200">
+                          <a:solidFill>
+                            <a:srgbClr val="1F2937"/>
+                          </a:solidFill>
+                        </a:rPr>
+                        <a:t>41.7 ± 1.4</a:t>
+                      </a:r>
+                    </a:p>
+                  </a:txBody>
+                  <a:tcPr anchor="ctr" marT="50800" marB="50800">
+                    <a:solidFill>
+                      <a:srgbClr val="F8FAFC"/>
+                    </a:solidFill>
+                  </a:tcPr>
+                </a:tc>
+              </a:tr>
+              <a:tr h="313508">
+                <a:tc>
+                  <a:txBody>
+                    <a:bodyPr/>
+                    <a:lstStyle/>
+                    <a:p>
+                      <a:pPr algn="l"/>
+                      <a:r>
+                        <a:rPr sz="1200">
+                          <a:solidFill>
+                            <a:srgbClr val="1F2937"/>
+                          </a:solidFill>
+                        </a:rPr>
+                        <a:t>p95_wait_minutes</a:t>
+                      </a:r>
+                    </a:p>
+                  </a:txBody>
+                  <a:tcPr anchor="ctr" marT="50800" marB="50800">
+                    <a:solidFill>
+                      <a:srgbClr val="FFFFFF"/>
+                    </a:solidFill>
+                  </a:tcPr>
+                </a:tc>
+                <a:tc>
+                  <a:txBody>
+                    <a:bodyPr/>
+                    <a:lstStyle/>
+                    <a:p>
+                      <a:pPr algn="ctr"/>
+                      <a:r>
+                        <a:rPr sz="1200">
+                          <a:solidFill>
+                            <a:srgbClr val="1F2937"/>
+                          </a:solidFill>
+                        </a:rPr>
+                        <a:t>GP</a:t>
+                      </a:r>
+                    </a:p>
+                  </a:txBody>
+                  <a:tcPr anchor="ctr" marT="50800" marB="50800">
+                    <a:solidFill>
+                      <a:srgbClr val="FFFFFF"/>
+                    </a:solidFill>
+                  </a:tcPr>
+                </a:tc>
+                <a:tc>
+                  <a:txBody>
+                    <a:bodyPr/>
+                    <a:lstStyle/>
+                    <a:p>
+                      <a:pPr algn="ctr"/>
+                      <a:r>
+                        <a:rPr sz="1200">
+                          <a:solidFill>
+                            <a:srgbClr val="1F2937"/>
+                          </a:solidFill>
+                        </a:rPr>
+                        <a:t>88.97% ± 0.44%</a:t>
+                      </a:r>
+                    </a:p>
+                  </a:txBody>
+                  <a:tcPr anchor="ctr" marT="50800" marB="50800">
+                    <a:solidFill>
+                      <a:srgbClr val="FFFFFF"/>
+                    </a:solidFill>
+                  </a:tcPr>
+                </a:tc>
+                <a:tc>
+                  <a:txBody>
+                    <a:bodyPr/>
+                    <a:lstStyle/>
+                    <a:p>
+                      <a:pPr algn="ctr"/>
+                      <a:r>
+                        <a:rPr sz="1200">
+                          <a:solidFill>
+                            <a:srgbClr val="1F2937"/>
+                          </a:solidFill>
+                        </a:rPr>
+                        <a:t>354.6 ± 11.5</a:t>
+                      </a:r>
+                    </a:p>
+                  </a:txBody>
+                  <a:tcPr anchor="ctr" marT="50800" marB="50800">
+                    <a:solidFill>
+                      <a:srgbClr val="FFFFFF"/>
+                    </a:solidFill>
+                  </a:tcPr>
+                </a:tc>
+              </a:tr>
+              <a:tr h="313508">
+                <a:tc>
+                  <a:txBody>
+                    <a:bodyPr/>
+                    <a:lstStyle/>
+                    <a:p>
+                      <a:pPr algn="l"/>
+                      <a:r>
+                        <a:rPr sz="1200">
+                          <a:solidFill>
+                            <a:srgbClr val="1F2937"/>
+                          </a:solidFill>
+                        </a:rPr>
+                        <a:t>p95_wait_minutes</a:t>
+                      </a:r>
+                    </a:p>
+                  </a:txBody>
+                  <a:tcPr anchor="ctr" marT="50800" marB="50800">
+                    <a:solidFill>
+                      <a:srgbClr val="F8FAFC"/>
+                    </a:solidFill>
+                  </a:tcPr>
+                </a:tc>
+                <a:tc>
+                  <a:txBody>
+                    <a:bodyPr/>
+                    <a:lstStyle/>
+                    <a:p>
+                      <a:pPr algn="ctr"/>
+                      <a:r>
+                        <a:rPr sz="1200">
+                          <a:solidFill>
+                            <a:srgbClr val="1F2937"/>
+                          </a:solidFill>
+                        </a:rPr>
+                        <a:t>Standard CP</a:t>
+                      </a:r>
+                    </a:p>
+                  </a:txBody>
+                  <a:tcPr anchor="ctr" marT="50800" marB="50800">
+                    <a:solidFill>
+                      <a:srgbClr val="F8FAFC"/>
+                    </a:solidFill>
+                  </a:tcPr>
+                </a:tc>
+                <a:tc>
+                  <a:txBody>
+                    <a:bodyPr/>
+                    <a:lstStyle/>
+                    <a:p>
+                      <a:pPr algn="ctr"/>
+                      <a:r>
+                        <a:rPr sz="1200">
+                          <a:solidFill>
+                            <a:srgbClr val="1F2937"/>
+                          </a:solidFill>
+                        </a:rPr>
+                        <a:t>90.06% ± 0.39%</a:t>
+                      </a:r>
+                    </a:p>
+                  </a:txBody>
+                  <a:tcPr anchor="ctr" marT="50800" marB="50800">
+                    <a:solidFill>
+                      <a:srgbClr val="F8FAFC"/>
+                    </a:solidFill>
+                  </a:tcPr>
+                </a:tc>
+                <a:tc>
+                  <a:txBody>
+                    <a:bodyPr/>
+                    <a:lstStyle/>
+                    <a:p>
+                      <a:pPr algn="ctr"/>
+                      <a:r>
+                        <a:rPr sz="1200">
+                          <a:solidFill>
+                            <a:srgbClr val="1F2937"/>
+                          </a:solidFill>
+                        </a:rPr>
+                        <a:t>377.1 ± 12.6</a:t>
+                      </a:r>
+                    </a:p>
+                  </a:txBody>
+                  <a:tcPr anchor="ctr" marT="50800" marB="50800">
+                    <a:solidFill>
+                      <a:srgbClr val="F8FAFC"/>
+                    </a:solidFill>
+                  </a:tcPr>
+                </a:tc>
+              </a:tr>
+              <a:tr h="313512">
+                <a:tc>
+                  <a:txBody>
+                    <a:bodyPr/>
+                    <a:lstStyle/>
+                    <a:p>
+                      <a:pPr algn="l"/>
+                      <a:r>
+                        <a:rPr sz="1200">
+                          <a:solidFill>
+                            <a:srgbClr val="1F2937"/>
+                          </a:solidFill>
+                        </a:rPr>
+                        <a:t>p95_wait_minutes</a:t>
+                      </a:r>
+                    </a:p>
+                  </a:txBody>
+                  <a:tcPr anchor="ctr" marT="50800" marB="50800">
+                    <a:solidFill>
+                      <a:srgbClr val="FFFFFF"/>
+                    </a:solidFill>
+                  </a:tcPr>
+                </a:tc>
+                <a:tc>
+                  <a:txBody>
+                    <a:bodyPr/>
+                    <a:lstStyle/>
+                    <a:p>
+                      <a:pPr algn="ctr"/>
+                      <a:r>
+                        <a:rPr sz="1200">
+                          <a:solidFill>
+                            <a:srgbClr val="1F2937"/>
+                          </a:solidFill>
+                        </a:rPr>
+                        <a:t>Mondrian CP</a:t>
+                      </a:r>
+                    </a:p>
+                  </a:txBody>
+                  <a:tcPr anchor="ctr" marT="50800" marB="50800">
+                    <a:solidFill>
+                      <a:srgbClr val="FFFFFF"/>
+                    </a:solidFill>
+                  </a:tcPr>
+                </a:tc>
+                <a:tc>
+                  <a:txBody>
+                    <a:bodyPr/>
+                    <a:lstStyle/>
+                    <a:p>
+                      <a:pPr algn="ctr"/>
+                      <a:r>
+                        <a:rPr sz="1200">
+                          <a:solidFill>
+                            <a:srgbClr val="1F2937"/>
+                          </a:solidFill>
+                        </a:rPr>
+                        <a:t>91.35% ± 0.46%</a:t>
+                      </a:r>
+                    </a:p>
+                  </a:txBody>
+                  <a:tcPr anchor="ctr" marT="50800" marB="50800">
+                    <a:solidFill>
+                      <a:srgbClr val="FFFFFF"/>
+                    </a:solidFill>
+                  </a:tcPr>
+                </a:tc>
+                <a:tc>
+                  <a:txBody>
+                    <a:bodyPr/>
+                    <a:lstStyle/>
+                    <a:p>
+                      <a:pPr algn="ctr"/>
+                      <a:r>
+                        <a:rPr sz="1200">
+                          <a:solidFill>
+                            <a:srgbClr val="1F2937"/>
+                          </a:solidFill>
+                        </a:rPr>
+                        <a:t>328.6 ± 13.4</a:t>
+                      </a:r>
+                    </a:p>
+                  </a:txBody>
+                  <a:tcPr anchor="ctr" marT="50800" marB="50800">
+                    <a:solidFill>
+                      <a:srgbClr val="FFFFFF"/>
+                    </a:solidFill>
+                  </a:tcPr>
+                </a:tc>
+              </a:tr>
+            </a:tbl>
+          </a:graphicData>
+        </a:graphic>
+      </p:graphicFrame>
+      <p:sp>
+        <p:nvSpPr>
+          <p:cNvPr id="9" name="Rectangle 8"/>
           <p:cNvSpPr/>
           <p:nvPr/>
         </p:nvSpPr>
         <p:spPr>
           <a:xfrm>
-            <a:off x="640080" y="2743200"/>
-            <a:ext cx="10881360" cy="2103120"/>
+            <a:off x="640080" y="4846320"/>
+            <a:ext cx="10881360" cy="1600200"/>
           </a:xfrm>
           <a:prstGeom prst="rect">
             <a:avLst/>
@@ -6873,69 +7488,14 @@
       </p:sp>
       <p:sp>
         <p:nvSpPr>
-          <p:cNvPr id="9" name="TextBox 8"/>
-          <p:cNvSpPr txBox="1"/>
-          <p:nvPr/>
-        </p:nvSpPr>
-        <p:spPr>
-          <a:xfrm>
-            <a:off x="914400" y="2971800"/>
-            <a:ext cx="10332720" cy="1737360"/>
-          </a:xfrm>
-          <a:prstGeom prst="rect">
-            <a:avLst/>
-          </a:prstGeom>
-          <a:noFill/>
-        </p:spPr>
-        <p:txBody>
-          <a:bodyPr wrap="square">
-            <a:spAutoFit/>
-          </a:bodyPr>
-          <a:lstStyle/>
-          <a:p>
-            <a:pPr>
-              <a:spcAft>
-                <a:spcPts val="1000"/>
-              </a:spcAft>
-            </a:pPr>
-            <a:r>
-              <a:rPr sz="1500">
-                <a:solidFill>
-                  <a:srgbClr val="1F2937"/>
-                </a:solidFill>
-                <a:latin typeface="Calibri"/>
-              </a:rPr>
-              <a:t>•  Marginal coverage limitation: tested. Mondrian CP closes the gap where a real gap exists (3 of 4 targets), and the one target where it doesn't help is explained, not hidden.</a:t>
-            </a:r>
-          </a:p>
-          <a:p>
-            <a:pPr>
-              <a:spcAft>
-                <a:spcPts val="1000"/>
-              </a:spcAft>
-            </a:pPr>
-            <a:r>
-              <a:rPr sz="1500">
-                <a:solidFill>
-                  <a:srgbClr val="1F2937"/>
-                </a:solidFill>
-                <a:latin typeface="Calibri"/>
-              </a:rPr>
-              <a:t>•  Exchangeability limitation: tested. Confirmed it breaks down outside the training distribution, with a specific, verified root cause rather than a generic "performance degrades" statement.</a:t>
-            </a:r>
-          </a:p>
-        </p:txBody>
-      </p:sp>
-      <p:sp>
-        <p:nvSpPr>
           <p:cNvPr id="10" name="TextBox 9"/>
           <p:cNvSpPr txBox="1"/>
           <p:nvPr/>
         </p:nvSpPr>
         <p:spPr>
           <a:xfrm>
-            <a:off x="640080" y="5074920"/>
-            <a:ext cx="10881360" cy="1097280"/>
+            <a:off x="914400" y="4983480"/>
+            <a:ext cx="10332720" cy="1371600"/>
           </a:xfrm>
           <a:prstGeom prst="rect">
             <a:avLst/>
@@ -6950,13 +7510,13 @@
           <a:p>
             <a:pPr algn="l"/>
             <a:r>
-              <a:rPr sz="1700" b="1" i="0">
-                <a:solidFill>
-                  <a:srgbClr val="16A34A"/>
+              <a:rPr sz="1300" b="0" i="0">
+                <a:solidFill>
+                  <a:srgbClr val="1F2937"/>
                 </a:solidFill>
                 <a:latin typeface="Calibri"/>
               </a:rPr>
-              <a:t>Yes — both limitations were tested in a domain they hadn't been tested in before, with concrete, quantified answers for each, not just a replication of the base paper's physics-domain results.</a:t>
+              <a:t>Paired t-test (same 30 draws underlie all methods): Mondrian CP's coverage advantage over both standard CP and GP is significant at p &lt; 0.001 on every one of the 4 targets, most p-values below 1e-05. With averaging, Mondrian CP's coverage now sits consistently above 90% while GP consistently undercovers — a statistically defensible claim, not just a directionally suggestive one.</a:t>
             </a:r>
           </a:p>
         </p:txBody>
@@ -7053,7 +7613,7 @@
                 </a:solidFill>
                 <a:latin typeface="Calibri"/>
               </a:rPr>
-              <a:t>HONESTY CHECK</a:t>
+              <a:t>PUBLICATION-RIGOR UPGRADE</a:t>
             </a:r>
           </a:p>
         </p:txBody>
@@ -7082,13 +7642,13 @@
           <a:p>
             <a:pPr algn="l"/>
             <a:r>
-              <a:rPr sz="2600" b="1" i="0">
+              <a:rPr sz="2400" b="1" i="0">
                 <a:solidFill>
                   <a:srgbClr val="1B2238"/>
                 </a:solidFill>
                 <a:latin typeface="Calibri"/>
               </a:rPr>
-              <a:t>Limitations &amp; What's Left</a:t>
+              <a:t>CQR: A Stronger, Adaptive Baseline</a:t>
             </a:r>
           </a:p>
         </p:txBody>
@@ -7167,7 +7727,2173 @@
                 </a:solidFill>
                 <a:latin typeface="Calibri"/>
               </a:rPr>
-              <a:t>16 / 16</a:t>
+              <a:t>16 / 21</a:t>
+            </a:r>
+          </a:p>
+        </p:txBody>
+      </p:sp>
+      <p:sp>
+        <p:nvSpPr>
+          <p:cNvPr id="7" name="TextBox 6"/>
+          <p:cNvSpPr txBox="1"/>
+          <p:nvPr/>
+        </p:nvSpPr>
+        <p:spPr>
+          <a:xfrm>
+            <a:off x="640080" y="1463040"/>
+            <a:ext cx="10881360" cy="914400"/>
+          </a:xfrm>
+          <a:prstGeom prst="rect">
+            <a:avLst/>
+          </a:prstGeom>
+          <a:noFill/>
+        </p:spPr>
+        <p:txBody>
+          <a:bodyPr wrap="square" anchor="t" lIns="0" rIns="0" tIns="0" bIns="0">
+            <a:spAutoFit/>
+          </a:bodyPr>
+          <a:lstStyle/>
+          <a:p>
+            <a:pPr algn="l"/>
+            <a:r>
+              <a:rPr sz="1500" b="0" i="0">
+                <a:solidFill>
+                  <a:srgbClr val="1F2937"/>
+                </a:solidFill>
+                <a:latin typeface="Calibri"/>
+              </a:rPr>
+              <a:t>Conformalized Quantile Regression (CQR) calibrates an interval that adapts to the local spread predicted by quantile regressors, instead of one fixed width (standard CP) or one fixed width per category (Mondrian CP) built from a mean predictor.</a:t>
+            </a:r>
+          </a:p>
+        </p:txBody>
+      </p:sp>
+      <p:graphicFrame>
+        <p:nvGraphicFramePr>
+          <p:cNvPr id="8" name="Table 7"/>
+          <p:cNvGraphicFramePr>
+            <a:graphicFrameLocks noGrp="1"/>
+          </p:cNvGraphicFramePr>
+          <p:nvPr/>
+        </p:nvGraphicFramePr>
+        <p:xfrm>
+          <a:off x="640080" y="2468880"/>
+          <a:ext cx="10881360" cy="1554480"/>
+        </p:xfrm>
+        <a:graphic>
+          <a:graphicData uri="http://schemas.openxmlformats.org/drawingml/2006/table">
+            <a:tbl>
+              <a:tblPr firstRow="1" bandRow="1">
+                <a:tableStyleId>{5C22544A-7EE6-4342-B048-85BDC9FD1C3A}</a:tableStyleId>
+              </a:tblPr>
+              <a:tblGrid>
+                <a:gridCol w="3200400"/>
+                <a:gridCol w="1920240"/>
+                <a:gridCol w="1920240"/>
+                <a:gridCol w="1920240"/>
+                <a:gridCol w="1920240"/>
+              </a:tblGrid>
+              <a:tr h="518160">
+                <a:tc>
+                  <a:txBody>
+                    <a:bodyPr/>
+                    <a:lstStyle/>
+                    <a:p>
+                      <a:pPr algn="l"/>
+                      <a:r>
+                        <a:rPr sz="1200" b="1">
+                          <a:solidFill>
+                            <a:srgbClr val="FFFFFF"/>
+                          </a:solidFill>
+                        </a:rPr>
+                        <a:t>Target</a:t>
+                      </a:r>
+                    </a:p>
+                  </a:txBody>
+                  <a:tcPr anchor="ctr" marT="50800" marB="50800">
+                    <a:solidFill>
+                      <a:srgbClr val="1E40AF"/>
+                    </a:solidFill>
+                  </a:tcPr>
+                </a:tc>
+                <a:tc>
+                  <a:txBody>
+                    <a:bodyPr/>
+                    <a:lstStyle/>
+                    <a:p>
+                      <a:pPr algn="ctr"/>
+                      <a:r>
+                        <a:rPr sz="1200" b="1">
+                          <a:solidFill>
+                            <a:srgbClr val="FFFFFF"/>
+                          </a:solidFill>
+                        </a:rPr>
+                        <a:t>Standard CP</a:t>
+                      </a:r>
+                    </a:p>
+                  </a:txBody>
+                  <a:tcPr anchor="ctr" marT="50800" marB="50800">
+                    <a:solidFill>
+                      <a:srgbClr val="1E40AF"/>
+                    </a:solidFill>
+                  </a:tcPr>
+                </a:tc>
+                <a:tc>
+                  <a:txBody>
+                    <a:bodyPr/>
+                    <a:lstStyle/>
+                    <a:p>
+                      <a:pPr algn="ctr"/>
+                      <a:r>
+                        <a:rPr sz="1200" b="1">
+                          <a:solidFill>
+                            <a:srgbClr val="FFFFFF"/>
+                          </a:solidFill>
+                        </a:rPr>
+                        <a:t>Mondrian CP</a:t>
+                      </a:r>
+                    </a:p>
+                  </a:txBody>
+                  <a:tcPr anchor="ctr" marT="50800" marB="50800">
+                    <a:solidFill>
+                      <a:srgbClr val="1E40AF"/>
+                    </a:solidFill>
+                  </a:tcPr>
+                </a:tc>
+                <a:tc>
+                  <a:txBody>
+                    <a:bodyPr/>
+                    <a:lstStyle/>
+                    <a:p>
+                      <a:pPr algn="ctr"/>
+                      <a:r>
+                        <a:rPr sz="1200" b="1">
+                          <a:solidFill>
+                            <a:srgbClr val="FFFFFF"/>
+                          </a:solidFill>
+                        </a:rPr>
+                        <a:t>CQR</a:t>
+                      </a:r>
+                    </a:p>
+                  </a:txBody>
+                  <a:tcPr anchor="ctr" marT="50800" marB="50800">
+                    <a:solidFill>
+                      <a:srgbClr val="1E40AF"/>
+                    </a:solidFill>
+                  </a:tcPr>
+                </a:tc>
+                <a:tc>
+                  <a:txBody>
+                    <a:bodyPr/>
+                    <a:lstStyle/>
+                    <a:p>
+                      <a:pPr algn="ctr"/>
+                      <a:r>
+                        <a:rPr sz="1200" b="1">
+                          <a:solidFill>
+                            <a:srgbClr val="FFFFFF"/>
+                          </a:solidFill>
+                        </a:rPr>
+                        <a:t>Mondrian CQR</a:t>
+                      </a:r>
+                    </a:p>
+                  </a:txBody>
+                  <a:tcPr anchor="ctr" marT="50800" marB="50800">
+                    <a:solidFill>
+                      <a:srgbClr val="1E40AF"/>
+                    </a:solidFill>
+                  </a:tcPr>
+                </a:tc>
+              </a:tr>
+              <a:tr h="518160">
+                <a:tc>
+                  <a:txBody>
+                    <a:bodyPr/>
+                    <a:lstStyle/>
+                    <a:p>
+                      <a:pPr algn="l"/>
+                      <a:r>
+                        <a:rPr sz="1200">
+                          <a:solidFill>
+                            <a:srgbClr val="1F2937"/>
+                          </a:solidFill>
+                        </a:rPr>
+                        <a:t>p95_wait_minutes (coverage)</a:t>
+                      </a:r>
+                    </a:p>
+                  </a:txBody>
+                  <a:tcPr anchor="ctr" marT="50800" marB="50800">
+                    <a:solidFill>
+                      <a:srgbClr val="F8FAFC"/>
+                    </a:solidFill>
+                  </a:tcPr>
+                </a:tc>
+                <a:tc>
+                  <a:txBody>
+                    <a:bodyPr/>
+                    <a:lstStyle/>
+                    <a:p>
+                      <a:pPr algn="ctr"/>
+                      <a:r>
+                        <a:rPr sz="1200">
+                          <a:solidFill>
+                            <a:srgbClr val="1F2937"/>
+                          </a:solidFill>
+                        </a:rPr>
+                        <a:t>90.1%</a:t>
+                      </a:r>
+                    </a:p>
+                  </a:txBody>
+                  <a:tcPr anchor="ctr" marT="50800" marB="50800">
+                    <a:solidFill>
+                      <a:srgbClr val="F8FAFC"/>
+                    </a:solidFill>
+                  </a:tcPr>
+                </a:tc>
+                <a:tc>
+                  <a:txBody>
+                    <a:bodyPr/>
+                    <a:lstStyle/>
+                    <a:p>
+                      <a:pPr algn="ctr"/>
+                      <a:r>
+                        <a:rPr sz="1200">
+                          <a:solidFill>
+                            <a:srgbClr val="1F2937"/>
+                          </a:solidFill>
+                        </a:rPr>
+                        <a:t>91.4%</a:t>
+                      </a:r>
+                    </a:p>
+                  </a:txBody>
+                  <a:tcPr anchor="ctr" marT="50800" marB="50800">
+                    <a:solidFill>
+                      <a:srgbClr val="F8FAFC"/>
+                    </a:solidFill>
+                  </a:tcPr>
+                </a:tc>
+                <a:tc>
+                  <a:txBody>
+                    <a:bodyPr/>
+                    <a:lstStyle/>
+                    <a:p>
+                      <a:pPr algn="ctr"/>
+                      <a:r>
+                        <a:rPr sz="1200">
+                          <a:solidFill>
+                            <a:srgbClr val="1F2937"/>
+                          </a:solidFill>
+                        </a:rPr>
+                        <a:t>90.9%</a:t>
+                      </a:r>
+                    </a:p>
+                  </a:txBody>
+                  <a:tcPr anchor="ctr" marT="50800" marB="50800">
+                    <a:solidFill>
+                      <a:srgbClr val="F8FAFC"/>
+                    </a:solidFill>
+                  </a:tcPr>
+                </a:tc>
+                <a:tc>
+                  <a:txBody>
+                    <a:bodyPr/>
+                    <a:lstStyle/>
+                    <a:p>
+                      <a:pPr algn="ctr"/>
+                      <a:r>
+                        <a:rPr sz="1200">
+                          <a:solidFill>
+                            <a:srgbClr val="1F2937"/>
+                          </a:solidFill>
+                        </a:rPr>
+                        <a:t>92.2%</a:t>
+                      </a:r>
+                    </a:p>
+                  </a:txBody>
+                  <a:tcPr anchor="ctr" marT="50800" marB="50800">
+                    <a:solidFill>
+                      <a:srgbClr val="F8FAFC"/>
+                    </a:solidFill>
+                  </a:tcPr>
+                </a:tc>
+              </a:tr>
+              <a:tr h="518160">
+                <a:tc>
+                  <a:txBody>
+                    <a:bodyPr/>
+                    <a:lstStyle/>
+                    <a:p>
+                      <a:pPr algn="l"/>
+                      <a:r>
+                        <a:rPr sz="1200">
+                          <a:solidFill>
+                            <a:srgbClr val="1F2937"/>
+                          </a:solidFill>
+                        </a:rPr>
+                        <a:t>p95_wait_minutes (width)</a:t>
+                      </a:r>
+                    </a:p>
+                  </a:txBody>
+                  <a:tcPr anchor="ctr" marT="50800" marB="50800">
+                    <a:solidFill>
+                      <a:srgbClr val="FFFFFF"/>
+                    </a:solidFill>
+                  </a:tcPr>
+                </a:tc>
+                <a:tc>
+                  <a:txBody>
+                    <a:bodyPr/>
+                    <a:lstStyle/>
+                    <a:p>
+                      <a:pPr algn="ctr"/>
+                      <a:r>
+                        <a:rPr sz="1200">
+                          <a:solidFill>
+                            <a:srgbClr val="1F2937"/>
+                          </a:solidFill>
+                        </a:rPr>
+                        <a:t>377.1</a:t>
+                      </a:r>
+                    </a:p>
+                  </a:txBody>
+                  <a:tcPr anchor="ctr" marT="50800" marB="50800">
+                    <a:solidFill>
+                      <a:srgbClr val="FFFFFF"/>
+                    </a:solidFill>
+                  </a:tcPr>
+                </a:tc>
+                <a:tc>
+                  <a:txBody>
+                    <a:bodyPr/>
+                    <a:lstStyle/>
+                    <a:p>
+                      <a:pPr algn="ctr"/>
+                      <a:r>
+                        <a:rPr sz="1200">
+                          <a:solidFill>
+                            <a:srgbClr val="1F2937"/>
+                          </a:solidFill>
+                        </a:rPr>
+                        <a:t>328.6</a:t>
+                      </a:r>
+                    </a:p>
+                  </a:txBody>
+                  <a:tcPr anchor="ctr" marT="50800" marB="50800">
+                    <a:solidFill>
+                      <a:srgbClr val="FFFFFF"/>
+                    </a:solidFill>
+                  </a:tcPr>
+                </a:tc>
+                <a:tc>
+                  <a:txBody>
+                    <a:bodyPr/>
+                    <a:lstStyle/>
+                    <a:p>
+                      <a:pPr algn="ctr"/>
+                      <a:r>
+                        <a:rPr sz="1200">
+                          <a:solidFill>
+                            <a:srgbClr val="1F2937"/>
+                          </a:solidFill>
+                        </a:rPr>
+                        <a:t>275.6</a:t>
+                      </a:r>
+                    </a:p>
+                  </a:txBody>
+                  <a:tcPr anchor="ctr" marT="50800" marB="50800">
+                    <a:solidFill>
+                      <a:srgbClr val="FFFFFF"/>
+                    </a:solidFill>
+                  </a:tcPr>
+                </a:tc>
+                <a:tc>
+                  <a:txBody>
+                    <a:bodyPr/>
+                    <a:lstStyle/>
+                    <a:p>
+                      <a:pPr algn="ctr"/>
+                      <a:r>
+                        <a:rPr sz="1200">
+                          <a:solidFill>
+                            <a:srgbClr val="1F2937"/>
+                          </a:solidFill>
+                        </a:rPr>
+                        <a:t>292.7</a:t>
+                      </a:r>
+                    </a:p>
+                  </a:txBody>
+                  <a:tcPr anchor="ctr" marT="50800" marB="50800">
+                    <a:solidFill>
+                      <a:srgbClr val="FFFFFF"/>
+                    </a:solidFill>
+                  </a:tcPr>
+                </a:tc>
+              </a:tr>
+            </a:tbl>
+          </a:graphicData>
+        </a:graphic>
+      </p:graphicFrame>
+      <p:sp>
+        <p:nvSpPr>
+          <p:cNvPr id="9" name="Rectangle 8"/>
+          <p:cNvSpPr/>
+          <p:nvPr/>
+        </p:nvSpPr>
+        <p:spPr>
+          <a:xfrm>
+            <a:off x="640080" y="4297680"/>
+            <a:ext cx="10881360" cy="2148840"/>
+          </a:xfrm>
+          <a:prstGeom prst="rect">
+            <a:avLst/>
+          </a:prstGeom>
+          <a:solidFill>
+            <a:srgbClr val="F8FAFC"/>
+          </a:solidFill>
+          <a:ln w="9525">
+            <a:solidFill>
+              <a:srgbClr val="E2E8F0"/>
+            </a:solidFill>
+          </a:ln>
+          <a:effectLst/>
+        </p:spPr>
+        <p:style>
+          <a:lnRef idx="1">
+            <a:schemeClr val="accent1"/>
+          </a:lnRef>
+          <a:fillRef idx="3">
+            <a:schemeClr val="accent1"/>
+          </a:fillRef>
+          <a:effectRef idx="2">
+            <a:schemeClr val="accent1"/>
+          </a:effectRef>
+          <a:fontRef idx="minor">
+            <a:schemeClr val="lt1"/>
+          </a:fontRef>
+        </p:style>
+        <p:txBody>
+          <a:bodyPr rtlCol="0" anchor="ctr"/>
+          <a:lstStyle/>
+          <a:p>
+            <a:pPr algn="ctr"/>
+          </a:p>
+        </p:txBody>
+      </p:sp>
+      <p:sp>
+        <p:nvSpPr>
+          <p:cNvPr id="10" name="TextBox 9"/>
+          <p:cNvSpPr txBox="1"/>
+          <p:nvPr/>
+        </p:nvSpPr>
+        <p:spPr>
+          <a:xfrm>
+            <a:off x="914400" y="4434840"/>
+            <a:ext cx="10332720" cy="1920240"/>
+          </a:xfrm>
+          <a:prstGeom prst="rect">
+            <a:avLst/>
+          </a:prstGeom>
+          <a:noFill/>
+        </p:spPr>
+        <p:txBody>
+          <a:bodyPr wrap="square" anchor="t" lIns="0" rIns="0" tIns="0" bIns="0">
+            <a:spAutoFit/>
+          </a:bodyPr>
+          <a:lstStyle/>
+          <a:p>
+            <a:pPr algn="l"/>
+            <a:r>
+              <a:rPr sz="1300" b="0" i="0">
+                <a:solidFill>
+                  <a:srgbClr val="1F2937"/>
+                </a:solidFill>
+                <a:latin typeface="Calibri"/>
+              </a:rPr>
+              <a:t>CQR dominates standard CP outright on p95_wait_minutes — equal-or-better coverage, ~27% narrower interval (p &lt; 0.005). Against Mondrian CP it's a genuine tradeoff: slightly lower coverage, but narrower — different points on the same coverage/width frontier. Combining both ideas (Mondrian CQR) wins on both axes simultaneously for p95_wait_minutes — higher coverage AND narrower than Mondrian CP alone. The five methods form a real frontier, not a strict ranking: each adds value in a different way.</a:t>
+            </a:r>
+          </a:p>
+        </p:txBody>
+      </p:sp>
+    </p:spTree>
+  </p:cSld>
+  <p:clrMapOvr>
+    <a:masterClrMapping/>
+  </p:clrMapOvr>
+</p:sld>
+</file>
+
+<file path=ppt/slides/slide17.xml><?xml version="1.0" encoding="utf-8"?>
+<p:sld xmlns:a="http://schemas.openxmlformats.org/drawingml/2006/main" xmlns:p="http://schemas.openxmlformats.org/presentationml/2006/main" xmlns:r="http://schemas.openxmlformats.org/officeDocument/2006/relationships">
+  <p:cSld>
+    <p:spTree>
+      <p:nvGrpSpPr>
+        <p:cNvPr id="1" name=""/>
+        <p:cNvGrpSpPr/>
+        <p:nvPr/>
+      </p:nvGrpSpPr>
+      <p:grpSpPr/>
+      <p:sp>
+        <p:nvSpPr>
+          <p:cNvPr id="2" name="Rectangle 1"/>
+          <p:cNvSpPr/>
+          <p:nvPr/>
+        </p:nvSpPr>
+        <p:spPr>
+          <a:xfrm>
+            <a:off x="0" y="0"/>
+            <a:ext cx="12191695" cy="82296"/>
+          </a:xfrm>
+          <a:prstGeom prst="rect">
+            <a:avLst/>
+          </a:prstGeom>
+          <a:solidFill>
+            <a:srgbClr val="3B82F6"/>
+          </a:solidFill>
+          <a:ln>
+            <a:noFill/>
+          </a:ln>
+          <a:effectLst/>
+        </p:spPr>
+        <p:style>
+          <a:lnRef idx="1">
+            <a:schemeClr val="accent1"/>
+          </a:lnRef>
+          <a:fillRef idx="3">
+            <a:schemeClr val="accent1"/>
+          </a:fillRef>
+          <a:effectRef idx="2">
+            <a:schemeClr val="accent1"/>
+          </a:effectRef>
+          <a:fontRef idx="minor">
+            <a:schemeClr val="lt1"/>
+          </a:fontRef>
+        </p:style>
+        <p:txBody>
+          <a:bodyPr rtlCol="0" anchor="ctr"/>
+          <a:lstStyle/>
+          <a:p>
+            <a:pPr algn="ctr"/>
+          </a:p>
+        </p:txBody>
+      </p:sp>
+      <p:sp>
+        <p:nvSpPr>
+          <p:cNvPr id="3" name="TextBox 2"/>
+          <p:cNvSpPr txBox="1"/>
+          <p:nvPr/>
+        </p:nvSpPr>
+        <p:spPr>
+          <a:xfrm>
+            <a:off x="548640" y="274320"/>
+            <a:ext cx="10515600" cy="320040"/>
+          </a:xfrm>
+          <a:prstGeom prst="rect">
+            <a:avLst/>
+          </a:prstGeom>
+          <a:noFill/>
+        </p:spPr>
+        <p:txBody>
+          <a:bodyPr wrap="square" anchor="t" lIns="0" rIns="0" tIns="0" bIns="0">
+            <a:spAutoFit/>
+          </a:bodyPr>
+          <a:lstStyle/>
+          <a:p>
+            <a:pPr algn="l"/>
+            <a:r>
+              <a:rPr sz="1300" b="1" i="0">
+                <a:solidFill>
+                  <a:srgbClr val="3B82F6"/>
+                </a:solidFill>
+                <a:latin typeface="Calibri"/>
+              </a:rPr>
+              <a:t>PUBLICATION-RIGOR UPGRADE</a:t>
+            </a:r>
+          </a:p>
+        </p:txBody>
+      </p:sp>
+      <p:sp>
+        <p:nvSpPr>
+          <p:cNvPr id="4" name="TextBox 3"/>
+          <p:cNvSpPr txBox="1"/>
+          <p:nvPr/>
+        </p:nvSpPr>
+        <p:spPr>
+          <a:xfrm>
+            <a:off x="548640" y="566928"/>
+            <a:ext cx="10881360" cy="640080"/>
+          </a:xfrm>
+          <a:prstGeom prst="rect">
+            <a:avLst/>
+          </a:prstGeom>
+          <a:noFill/>
+        </p:spPr>
+        <p:txBody>
+          <a:bodyPr wrap="square" anchor="t" lIns="0" rIns="0" tIns="0" bIns="0">
+            <a:spAutoFit/>
+          </a:bodyPr>
+          <a:lstStyle/>
+          <a:p>
+            <a:pPr algn="l"/>
+            <a:r>
+              <a:rPr sz="2400" b="1" i="0">
+                <a:solidFill>
+                  <a:srgbClr val="1B2238"/>
+                </a:solidFill>
+                <a:latin typeface="Calibri"/>
+              </a:rPr>
+              <a:t>Robustness Check: A Second Surrogate</a:t>
+            </a:r>
+          </a:p>
+        </p:txBody>
+      </p:sp>
+      <p:sp>
+        <p:nvSpPr>
+          <p:cNvPr id="5" name="Rectangle 4"/>
+          <p:cNvSpPr/>
+          <p:nvPr/>
+        </p:nvSpPr>
+        <p:spPr>
+          <a:xfrm>
+            <a:off x="548640" y="1170432"/>
+            <a:ext cx="1005840" cy="38100"/>
+          </a:xfrm>
+          <a:prstGeom prst="rect">
+            <a:avLst/>
+          </a:prstGeom>
+          <a:solidFill>
+            <a:srgbClr val="3B82F6"/>
+          </a:solidFill>
+          <a:ln>
+            <a:noFill/>
+          </a:ln>
+          <a:effectLst/>
+        </p:spPr>
+        <p:style>
+          <a:lnRef idx="1">
+            <a:schemeClr val="accent1"/>
+          </a:lnRef>
+          <a:fillRef idx="3">
+            <a:schemeClr val="accent1"/>
+          </a:fillRef>
+          <a:effectRef idx="2">
+            <a:schemeClr val="accent1"/>
+          </a:effectRef>
+          <a:fontRef idx="minor">
+            <a:schemeClr val="lt1"/>
+          </a:fontRef>
+        </p:style>
+        <p:txBody>
+          <a:bodyPr rtlCol="0" anchor="ctr"/>
+          <a:lstStyle/>
+          <a:p>
+            <a:pPr algn="ctr"/>
+          </a:p>
+        </p:txBody>
+      </p:sp>
+      <p:sp>
+        <p:nvSpPr>
+          <p:cNvPr id="6" name="TextBox 5"/>
+          <p:cNvSpPr txBox="1"/>
+          <p:nvPr/>
+        </p:nvSpPr>
+        <p:spPr>
+          <a:xfrm>
+            <a:off x="11155680" y="6446520"/>
+            <a:ext cx="822960" cy="320040"/>
+          </a:xfrm>
+          <a:prstGeom prst="rect">
+            <a:avLst/>
+          </a:prstGeom>
+          <a:noFill/>
+        </p:spPr>
+        <p:txBody>
+          <a:bodyPr wrap="square" anchor="t" lIns="0" rIns="0" tIns="0" bIns="0">
+            <a:spAutoFit/>
+          </a:bodyPr>
+          <a:lstStyle/>
+          <a:p>
+            <a:pPr algn="r"/>
+            <a:r>
+              <a:rPr sz="1100" b="0" i="0">
+                <a:solidFill>
+                  <a:srgbClr val="6B7280"/>
+                </a:solidFill>
+                <a:latin typeface="Calibri"/>
+              </a:rPr>
+              <a:t>17 / 21</a:t>
+            </a:r>
+          </a:p>
+        </p:txBody>
+      </p:sp>
+      <p:sp>
+        <p:nvSpPr>
+          <p:cNvPr id="7" name="TextBox 6"/>
+          <p:cNvSpPr txBox="1"/>
+          <p:nvPr/>
+        </p:nvSpPr>
+        <p:spPr>
+          <a:xfrm>
+            <a:off x="640080" y="1463040"/>
+            <a:ext cx="10881360" cy="822960"/>
+          </a:xfrm>
+          <a:prstGeom prst="rect">
+            <a:avLst/>
+          </a:prstGeom>
+          <a:noFill/>
+        </p:spPr>
+        <p:txBody>
+          <a:bodyPr wrap="square" anchor="t" lIns="0" rIns="0" tIns="0" bIns="0">
+            <a:spAutoFit/>
+          </a:bodyPr>
+          <a:lstStyle/>
+          <a:p>
+            <a:pPr algn="l"/>
+            <a:r>
+              <a:rPr sz="1500" b="0" i="0">
+                <a:solidFill>
+                  <a:srgbClr val="1F2937"/>
+                </a:solidFill>
+                <a:latin typeface="Calibri"/>
+              </a:rPr>
+              <a:t>Trained an MLP (neural network) surrogate — nearly identical in-distribution accuracy to gradient boosting (R² within ~0.01 on every target) — and re-ran the exchangeability stress test to see if the coverage collapse was specific to tree-based extrapolation.</a:t>
+            </a:r>
+          </a:p>
+        </p:txBody>
+      </p:sp>
+      <p:graphicFrame>
+        <p:nvGraphicFramePr>
+          <p:cNvPr id="8" name="Table 7"/>
+          <p:cNvGraphicFramePr>
+            <a:graphicFrameLocks noGrp="1"/>
+          </p:cNvGraphicFramePr>
+          <p:nvPr/>
+        </p:nvGraphicFramePr>
+        <p:xfrm>
+          <a:off x="640080" y="2377440"/>
+          <a:ext cx="10881360" cy="1280160"/>
+        </p:xfrm>
+        <a:graphic>
+          <a:graphicData uri="http://schemas.openxmlformats.org/drawingml/2006/table">
+            <a:tbl>
+              <a:tblPr firstRow="1" bandRow="1">
+                <a:tableStyleId>{5C22544A-7EE6-4342-B048-85BDC9FD1C3A}</a:tableStyleId>
+              </a:tblPr>
+              <a:tblGrid>
+                <a:gridCol w="2103120"/>
+                <a:gridCol w="1737360"/>
+                <a:gridCol w="1737360"/>
+                <a:gridCol w="1828800"/>
+                <a:gridCol w="1737360"/>
+                <a:gridCol w="1737360"/>
+              </a:tblGrid>
+              <a:tr h="426720">
+                <a:tc>
+                  <a:txBody>
+                    <a:bodyPr/>
+                    <a:lstStyle/>
+                    <a:p>
+                      <a:pPr algn="l"/>
+                      <a:r>
+                        <a:rPr sz="1100" b="1">
+                          <a:solidFill>
+                            <a:srgbClr val="FFFFFF"/>
+                          </a:solidFill>
+                        </a:rPr>
+                        <a:t>n_capacity=30</a:t>
+                      </a:r>
+                    </a:p>
+                  </a:txBody>
+                  <a:tcPr anchor="ctr" marT="50800" marB="50800">
+                    <a:solidFill>
+                      <a:srgbClr val="1E40AF"/>
+                    </a:solidFill>
+                  </a:tcPr>
+                </a:tc>
+                <a:tc>
+                  <a:txBody>
+                    <a:bodyPr/>
+                    <a:lstStyle/>
+                    <a:p>
+                      <a:pPr algn="ctr"/>
+                      <a:r>
+                        <a:rPr sz="1100" b="1">
+                          <a:solidFill>
+                            <a:srgbClr val="FFFFFF"/>
+                          </a:solidFill>
+                        </a:rPr>
+                        <a:t>Arrival 1.0x</a:t>
+                      </a:r>
+                    </a:p>
+                  </a:txBody>
+                  <a:tcPr anchor="ctr" marT="50800" marB="50800">
+                    <a:solidFill>
+                      <a:srgbClr val="1E40AF"/>
+                    </a:solidFill>
+                  </a:tcPr>
+                </a:tc>
+                <a:tc>
+                  <a:txBody>
+                    <a:bodyPr/>
+                    <a:lstStyle/>
+                    <a:p>
+                      <a:pPr algn="ctr"/>
+                      <a:r>
+                        <a:rPr sz="1100" b="1">
+                          <a:solidFill>
+                            <a:srgbClr val="FFFFFF"/>
+                          </a:solidFill>
+                        </a:rPr>
+                        <a:t>Arrival 1.3x</a:t>
+                      </a:r>
+                    </a:p>
+                  </a:txBody>
+                  <a:tcPr anchor="ctr" marT="50800" marB="50800">
+                    <a:solidFill>
+                      <a:srgbClr val="1E40AF"/>
+                    </a:solidFill>
+                  </a:tcPr>
+                </a:tc>
+                <a:tc>
+                  <a:txBody>
+                    <a:bodyPr/>
+                    <a:lstStyle/>
+                    <a:p>
+                      <a:pPr algn="ctr"/>
+                      <a:r>
+                        <a:rPr sz="1100" b="1">
+                          <a:solidFill>
+                            <a:srgbClr val="FFFFFF"/>
+                          </a:solidFill>
+                        </a:rPr>
+                        <a:t>Arrival 2.0x</a:t>
+                      </a:r>
+                    </a:p>
+                  </a:txBody>
+                  <a:tcPr anchor="ctr" marT="50800" marB="50800">
+                    <a:solidFill>
+                      <a:srgbClr val="1E40AF"/>
+                    </a:solidFill>
+                  </a:tcPr>
+                </a:tc>
+                <a:tc>
+                  <a:txBody>
+                    <a:bodyPr/>
+                    <a:lstStyle/>
+                    <a:p>
+                      <a:pPr algn="ctr"/>
+                      <a:r>
+                        <a:rPr sz="1100" b="1">
+                          <a:solidFill>
+                            <a:srgbClr val="FFFFFF"/>
+                          </a:solidFill>
+                        </a:rPr>
+                        <a:t>Arrival 3.0x</a:t>
+                      </a:r>
+                    </a:p>
+                  </a:txBody>
+                  <a:tcPr anchor="ctr" marT="50800" marB="50800">
+                    <a:solidFill>
+                      <a:srgbClr val="1E40AF"/>
+                    </a:solidFill>
+                  </a:tcPr>
+                </a:tc>
+                <a:tc>
+                  <a:txBody>
+                    <a:bodyPr/>
+                    <a:lstStyle/>
+                    <a:p>
+                      <a:pPr algn="ctr"/>
+                      <a:r>
+                        <a:rPr sz="1100" b="1">
+                          <a:solidFill>
+                            <a:srgbClr val="FFFFFF"/>
+                          </a:solidFill>
+                        </a:rPr>
+                        <a:t>True (3.0x)</a:t>
+                      </a:r>
+                    </a:p>
+                  </a:txBody>
+                  <a:tcPr anchor="ctr" marT="50800" marB="50800">
+                    <a:solidFill>
+                      <a:srgbClr val="1E40AF"/>
+                    </a:solidFill>
+                  </a:tcPr>
+                </a:tc>
+              </a:tr>
+              <a:tr h="426720">
+                <a:tc>
+                  <a:txBody>
+                    <a:bodyPr/>
+                    <a:lstStyle/>
+                    <a:p>
+                      <a:pPr algn="l"/>
+                      <a:r>
+                        <a:rPr sz="1100">
+                          <a:solidFill>
+                            <a:srgbClr val="1F2937"/>
+                          </a:solidFill>
+                        </a:rPr>
+                        <a:t>GBR prediction</a:t>
+                      </a:r>
+                    </a:p>
+                  </a:txBody>
+                  <a:tcPr anchor="ctr" marT="50800" marB="50800">
+                    <a:solidFill>
+                      <a:srgbClr val="F8FAFC"/>
+                    </a:solidFill>
+                  </a:tcPr>
+                </a:tc>
+                <a:tc>
+                  <a:txBody>
+                    <a:bodyPr/>
+                    <a:lstStyle/>
+                    <a:p>
+                      <a:pPr algn="ctr"/>
+                      <a:r>
+                        <a:rPr sz="1100">
+                          <a:solidFill>
+                            <a:srgbClr val="1F2937"/>
+                          </a:solidFill>
+                        </a:rPr>
+                        <a:t>240.5</a:t>
+                      </a:r>
+                    </a:p>
+                  </a:txBody>
+                  <a:tcPr anchor="ctr" marT="50800" marB="50800">
+                    <a:solidFill>
+                      <a:srgbClr val="F8FAFC"/>
+                    </a:solidFill>
+                  </a:tcPr>
+                </a:tc>
+                <a:tc>
+                  <a:txBody>
+                    <a:bodyPr/>
+                    <a:lstStyle/>
+                    <a:p>
+                      <a:pPr algn="ctr"/>
+                      <a:r>
+                        <a:rPr sz="1100">
+                          <a:solidFill>
+                            <a:srgbClr val="1F2937"/>
+                          </a:solidFill>
+                        </a:rPr>
+                        <a:t>247.8</a:t>
+                      </a:r>
+                    </a:p>
+                  </a:txBody>
+                  <a:tcPr anchor="ctr" marT="50800" marB="50800">
+                    <a:solidFill>
+                      <a:srgbClr val="F8FAFC"/>
+                    </a:solidFill>
+                  </a:tcPr>
+                </a:tc>
+                <a:tc>
+                  <a:txBody>
+                    <a:bodyPr/>
+                    <a:lstStyle/>
+                    <a:p>
+                      <a:pPr algn="ctr"/>
+                      <a:r>
+                        <a:rPr sz="1100">
+                          <a:solidFill>
+                            <a:srgbClr val="1F2937"/>
+                          </a:solidFill>
+                        </a:rPr>
+                        <a:t>247.8 (frozen)</a:t>
+                      </a:r>
+                    </a:p>
+                  </a:txBody>
+                  <a:tcPr anchor="ctr" marT="50800" marB="50800">
+                    <a:solidFill>
+                      <a:srgbClr val="F8FAFC"/>
+                    </a:solidFill>
+                  </a:tcPr>
+                </a:tc>
+                <a:tc>
+                  <a:txBody>
+                    <a:bodyPr/>
+                    <a:lstStyle/>
+                    <a:p>
+                      <a:pPr algn="ctr"/>
+                      <a:r>
+                        <a:rPr sz="1100">
+                          <a:solidFill>
+                            <a:srgbClr val="1F2937"/>
+                          </a:solidFill>
+                        </a:rPr>
+                        <a:t>247.8 (frozen)</a:t>
+                      </a:r>
+                    </a:p>
+                  </a:txBody>
+                  <a:tcPr anchor="ctr" marT="50800" marB="50800">
+                    <a:solidFill>
+                      <a:srgbClr val="F8FAFC"/>
+                    </a:solidFill>
+                  </a:tcPr>
+                </a:tc>
+                <a:tc>
+                  <a:txBody>
+                    <a:bodyPr/>
+                    <a:lstStyle/>
+                    <a:p>
+                      <a:pPr algn="ctr"/>
+                      <a:r>
+                        <a:rPr sz="1100">
+                          <a:solidFill>
+                            <a:srgbClr val="1F2937"/>
+                          </a:solidFill>
+                        </a:rPr>
+                        <a:t>280.9</a:t>
+                      </a:r>
+                    </a:p>
+                  </a:txBody>
+                  <a:tcPr anchor="ctr" marT="50800" marB="50800">
+                    <a:solidFill>
+                      <a:srgbClr val="F8FAFC"/>
+                    </a:solidFill>
+                  </a:tcPr>
+                </a:tc>
+              </a:tr>
+              <a:tr h="426720">
+                <a:tc>
+                  <a:txBody>
+                    <a:bodyPr/>
+                    <a:lstStyle/>
+                    <a:p>
+                      <a:pPr algn="l"/>
+                      <a:r>
+                        <a:rPr sz="1100">
+                          <a:solidFill>
+                            <a:srgbClr val="1F2937"/>
+                          </a:solidFill>
+                        </a:rPr>
+                        <a:t>MLP prediction</a:t>
+                      </a:r>
+                    </a:p>
+                  </a:txBody>
+                  <a:tcPr anchor="ctr" marT="50800" marB="50800">
+                    <a:solidFill>
+                      <a:srgbClr val="FFFFFF"/>
+                    </a:solidFill>
+                  </a:tcPr>
+                </a:tc>
+                <a:tc>
+                  <a:txBody>
+                    <a:bodyPr/>
+                    <a:lstStyle/>
+                    <a:p>
+                      <a:pPr algn="ctr"/>
+                      <a:r>
+                        <a:rPr sz="1100">
+                          <a:solidFill>
+                            <a:srgbClr val="1F2937"/>
+                          </a:solidFill>
+                        </a:rPr>
+                        <a:t>234.8</a:t>
+                      </a:r>
+                    </a:p>
+                  </a:txBody>
+                  <a:tcPr anchor="ctr" marT="50800" marB="50800">
+                    <a:solidFill>
+                      <a:srgbClr val="FFFFFF"/>
+                    </a:solidFill>
+                  </a:tcPr>
+                </a:tc>
+                <a:tc>
+                  <a:txBody>
+                    <a:bodyPr/>
+                    <a:lstStyle/>
+                    <a:p>
+                      <a:pPr algn="ctr"/>
+                      <a:r>
+                        <a:rPr sz="1100">
+                          <a:solidFill>
+                            <a:srgbClr val="1F2937"/>
+                          </a:solidFill>
+                        </a:rPr>
+                        <a:t>245.8</a:t>
+                      </a:r>
+                    </a:p>
+                  </a:txBody>
+                  <a:tcPr anchor="ctr" marT="50800" marB="50800">
+                    <a:solidFill>
+                      <a:srgbClr val="FFFFFF"/>
+                    </a:solidFill>
+                  </a:tcPr>
+                </a:tc>
+                <a:tc>
+                  <a:txBody>
+                    <a:bodyPr/>
+                    <a:lstStyle/>
+                    <a:p>
+                      <a:pPr algn="ctr"/>
+                      <a:r>
+                        <a:rPr sz="1100">
+                          <a:solidFill>
+                            <a:srgbClr val="1F2937"/>
+                          </a:solidFill>
+                        </a:rPr>
+                        <a:t>336.5</a:t>
+                      </a:r>
+                    </a:p>
+                  </a:txBody>
+                  <a:tcPr anchor="ctr" marT="50800" marB="50800">
+                    <a:solidFill>
+                      <a:srgbClr val="FFFFFF"/>
+                    </a:solidFill>
+                  </a:tcPr>
+                </a:tc>
+                <a:tc>
+                  <a:txBody>
+                    <a:bodyPr/>
+                    <a:lstStyle/>
+                    <a:p>
+                      <a:pPr algn="ctr"/>
+                      <a:r>
+                        <a:rPr sz="1100">
+                          <a:solidFill>
+                            <a:srgbClr val="1F2937"/>
+                          </a:solidFill>
+                        </a:rPr>
+                        <a:t>521.2</a:t>
+                      </a:r>
+                    </a:p>
+                  </a:txBody>
+                  <a:tcPr anchor="ctr" marT="50800" marB="50800">
+                    <a:solidFill>
+                      <a:srgbClr val="FFFFFF"/>
+                    </a:solidFill>
+                  </a:tcPr>
+                </a:tc>
+                <a:tc>
+                  <a:txBody>
+                    <a:bodyPr/>
+                    <a:lstStyle/>
+                    <a:p>
+                      <a:pPr algn="ctr"/>
+                      <a:r>
+                        <a:rPr sz="1100">
+                          <a:solidFill>
+                            <a:srgbClr val="1F2937"/>
+                          </a:solidFill>
+                        </a:rPr>
+                        <a:t>280.9</a:t>
+                      </a:r>
+                    </a:p>
+                  </a:txBody>
+                  <a:tcPr anchor="ctr" marT="50800" marB="50800">
+                    <a:solidFill>
+                      <a:srgbClr val="FFFFFF"/>
+                    </a:solidFill>
+                  </a:tcPr>
+                </a:tc>
+              </a:tr>
+            </a:tbl>
+          </a:graphicData>
+        </a:graphic>
+      </p:graphicFrame>
+      <p:sp>
+        <p:nvSpPr>
+          <p:cNvPr id="9" name="Rectangle 8"/>
+          <p:cNvSpPr/>
+          <p:nvPr/>
+        </p:nvSpPr>
+        <p:spPr>
+          <a:xfrm>
+            <a:off x="640080" y="3886200"/>
+            <a:ext cx="10881360" cy="2560320"/>
+          </a:xfrm>
+          <a:prstGeom prst="rect">
+            <a:avLst/>
+          </a:prstGeom>
+          <a:solidFill>
+            <a:srgbClr val="F8FAFC"/>
+          </a:solidFill>
+          <a:ln w="9525">
+            <a:solidFill>
+              <a:srgbClr val="E2E8F0"/>
+            </a:solidFill>
+          </a:ln>
+          <a:effectLst/>
+        </p:spPr>
+        <p:style>
+          <a:lnRef idx="1">
+            <a:schemeClr val="accent1"/>
+          </a:lnRef>
+          <a:fillRef idx="3">
+            <a:schemeClr val="accent1"/>
+          </a:fillRef>
+          <a:effectRef idx="2">
+            <a:schemeClr val="accent1"/>
+          </a:effectRef>
+          <a:fontRef idx="minor">
+            <a:schemeClr val="lt1"/>
+          </a:fontRef>
+        </p:style>
+        <p:txBody>
+          <a:bodyPr rtlCol="0" anchor="ctr"/>
+          <a:lstStyle/>
+          <a:p>
+            <a:pPr algn="ctr"/>
+          </a:p>
+        </p:txBody>
+      </p:sp>
+      <p:sp>
+        <p:nvSpPr>
+          <p:cNvPr id="10" name="TextBox 9"/>
+          <p:cNvSpPr txBox="1"/>
+          <p:nvPr/>
+        </p:nvSpPr>
+        <p:spPr>
+          <a:xfrm>
+            <a:off x="914400" y="4023360"/>
+            <a:ext cx="10332720" cy="2331720"/>
+          </a:xfrm>
+          <a:prstGeom prst="rect">
+            <a:avLst/>
+          </a:prstGeom>
+          <a:noFill/>
+        </p:spPr>
+        <p:txBody>
+          <a:bodyPr wrap="square" anchor="t" lIns="0" rIns="0" tIns="0" bIns="0">
+            <a:spAutoFit/>
+          </a:bodyPr>
+          <a:lstStyle/>
+          <a:p>
+            <a:pPr algn="l"/>
+            <a:r>
+              <a:rPr sz="1300" b="0" i="0">
+                <a:solidFill>
+                  <a:srgbClr val="1F2937"/>
+                </a:solidFill>
+                <a:latin typeface="Calibri"/>
+              </a:rPr>
+              <a:t>Counter-intuitive result: the true DES output saturates at extreme overload (the same day-boundary censoring effect from Slide 7 — fewer patients finish within a day). GBR's frozen prediction happens to land close to that saturating value by coincidence (error ~33). The MLP keeps extrapolating the upward trend it learned near the training boundary and overshoots massively (error ~240, 7x worse) — n_patients and mean_total_minutes both hit exactly 0% coverage with the MLP by 2.0x severity, worse than GBR's 31.7%/4.7% at 3.0x. The ability to extrapolate is not automatically better than not being able to — confidently-wrong extrapolation is worse than frozen-but-plausible extrapolation here. Strengthens the exchangeability finding: the breakdown isn't one architecture's quirk.</a:t>
+            </a:r>
+          </a:p>
+        </p:txBody>
+      </p:sp>
+    </p:spTree>
+  </p:cSld>
+  <p:clrMapOvr>
+    <a:masterClrMapping/>
+  </p:clrMapOvr>
+</p:sld>
+</file>
+
+<file path=ppt/slides/slide18.xml><?xml version="1.0" encoding="utf-8"?>
+<p:sld xmlns:a="http://schemas.openxmlformats.org/drawingml/2006/main" xmlns:p="http://schemas.openxmlformats.org/presentationml/2006/main" xmlns:r="http://schemas.openxmlformats.org/officeDocument/2006/relationships">
+  <p:cSld>
+    <p:spTree>
+      <p:nvGrpSpPr>
+        <p:cNvPr id="1" name=""/>
+        <p:cNvGrpSpPr/>
+        <p:nvPr/>
+      </p:nvGrpSpPr>
+      <p:grpSpPr/>
+      <p:sp>
+        <p:nvSpPr>
+          <p:cNvPr id="2" name="Rectangle 1"/>
+          <p:cNvSpPr/>
+          <p:nvPr/>
+        </p:nvSpPr>
+        <p:spPr>
+          <a:xfrm>
+            <a:off x="0" y="0"/>
+            <a:ext cx="12191695" cy="82296"/>
+          </a:xfrm>
+          <a:prstGeom prst="rect">
+            <a:avLst/>
+          </a:prstGeom>
+          <a:solidFill>
+            <a:srgbClr val="3B82F6"/>
+          </a:solidFill>
+          <a:ln>
+            <a:noFill/>
+          </a:ln>
+          <a:effectLst/>
+        </p:spPr>
+        <p:style>
+          <a:lnRef idx="1">
+            <a:schemeClr val="accent1"/>
+          </a:lnRef>
+          <a:fillRef idx="3">
+            <a:schemeClr val="accent1"/>
+          </a:fillRef>
+          <a:effectRef idx="2">
+            <a:schemeClr val="accent1"/>
+          </a:effectRef>
+          <a:fontRef idx="minor">
+            <a:schemeClr val="lt1"/>
+          </a:fontRef>
+        </p:style>
+        <p:txBody>
+          <a:bodyPr rtlCol="0" anchor="ctr"/>
+          <a:lstStyle/>
+          <a:p>
+            <a:pPr algn="ctr"/>
+          </a:p>
+        </p:txBody>
+      </p:sp>
+      <p:sp>
+        <p:nvSpPr>
+          <p:cNvPr id="3" name="TextBox 2"/>
+          <p:cNvSpPr txBox="1"/>
+          <p:nvPr/>
+        </p:nvSpPr>
+        <p:spPr>
+          <a:xfrm>
+            <a:off x="548640" y="274320"/>
+            <a:ext cx="10515600" cy="320040"/>
+          </a:xfrm>
+          <a:prstGeom prst="rect">
+            <a:avLst/>
+          </a:prstGeom>
+          <a:noFill/>
+        </p:spPr>
+        <p:txBody>
+          <a:bodyPr wrap="square" anchor="t" lIns="0" rIns="0" tIns="0" bIns="0">
+            <a:spAutoFit/>
+          </a:bodyPr>
+          <a:lstStyle/>
+          <a:p>
+            <a:pPr algn="l"/>
+            <a:r>
+              <a:rPr sz="1300" b="1" i="0">
+                <a:solidFill>
+                  <a:srgbClr val="3B82F6"/>
+                </a:solidFill>
+                <a:latin typeface="Calibri"/>
+              </a:rPr>
+              <a:t>PUBLICATION-RIGOR UPGRADE</a:t>
+            </a:r>
+          </a:p>
+        </p:txBody>
+      </p:sp>
+      <p:sp>
+        <p:nvSpPr>
+          <p:cNvPr id="4" name="TextBox 3"/>
+          <p:cNvSpPr txBox="1"/>
+          <p:nvPr/>
+        </p:nvSpPr>
+        <p:spPr>
+          <a:xfrm>
+            <a:off x="548640" y="566928"/>
+            <a:ext cx="10881360" cy="640080"/>
+          </a:xfrm>
+          <a:prstGeom prst="rect">
+            <a:avLst/>
+          </a:prstGeom>
+          <a:noFill/>
+        </p:spPr>
+        <p:txBody>
+          <a:bodyPr wrap="square" anchor="t" lIns="0" rIns="0" tIns="0" bIns="0">
+            <a:spAutoFit/>
+          </a:bodyPr>
+          <a:lstStyle/>
+          <a:p>
+            <a:pPr algn="l"/>
+            <a:r>
+              <a:rPr sz="2400" b="1" i="0">
+                <a:solidFill>
+                  <a:srgbClr val="1B2238"/>
+                </a:solidFill>
+                <a:latin typeface="Calibri"/>
+              </a:rPr>
+              <a:t>Generalizability: A Second Department</a:t>
+            </a:r>
+          </a:p>
+        </p:txBody>
+      </p:sp>
+      <p:sp>
+        <p:nvSpPr>
+          <p:cNvPr id="5" name="Rectangle 4"/>
+          <p:cNvSpPr/>
+          <p:nvPr/>
+        </p:nvSpPr>
+        <p:spPr>
+          <a:xfrm>
+            <a:off x="548640" y="1170432"/>
+            <a:ext cx="1005840" cy="38100"/>
+          </a:xfrm>
+          <a:prstGeom prst="rect">
+            <a:avLst/>
+          </a:prstGeom>
+          <a:solidFill>
+            <a:srgbClr val="3B82F6"/>
+          </a:solidFill>
+          <a:ln>
+            <a:noFill/>
+          </a:ln>
+          <a:effectLst/>
+        </p:spPr>
+        <p:style>
+          <a:lnRef idx="1">
+            <a:schemeClr val="accent1"/>
+          </a:lnRef>
+          <a:fillRef idx="3">
+            <a:schemeClr val="accent1"/>
+          </a:fillRef>
+          <a:effectRef idx="2">
+            <a:schemeClr val="accent1"/>
+          </a:effectRef>
+          <a:fontRef idx="minor">
+            <a:schemeClr val="lt1"/>
+          </a:fontRef>
+        </p:style>
+        <p:txBody>
+          <a:bodyPr rtlCol="0" anchor="ctr"/>
+          <a:lstStyle/>
+          <a:p>
+            <a:pPr algn="ctr"/>
+          </a:p>
+        </p:txBody>
+      </p:sp>
+      <p:sp>
+        <p:nvSpPr>
+          <p:cNvPr id="6" name="TextBox 5"/>
+          <p:cNvSpPr txBox="1"/>
+          <p:nvPr/>
+        </p:nvSpPr>
+        <p:spPr>
+          <a:xfrm>
+            <a:off x="11155680" y="6446520"/>
+            <a:ext cx="822960" cy="320040"/>
+          </a:xfrm>
+          <a:prstGeom prst="rect">
+            <a:avLst/>
+          </a:prstGeom>
+          <a:noFill/>
+        </p:spPr>
+        <p:txBody>
+          <a:bodyPr wrap="square" anchor="t" lIns="0" rIns="0" tIns="0" bIns="0">
+            <a:spAutoFit/>
+          </a:bodyPr>
+          <a:lstStyle/>
+          <a:p>
+            <a:pPr algn="r"/>
+            <a:r>
+              <a:rPr sz="1100" b="0" i="0">
+                <a:solidFill>
+                  <a:srgbClr val="6B7280"/>
+                </a:solidFill>
+                <a:latin typeface="Calibri"/>
+              </a:rPr>
+              <a:t>18 / 21</a:t>
+            </a:r>
+          </a:p>
+        </p:txBody>
+      </p:sp>
+      <p:sp>
+        <p:nvSpPr>
+          <p:cNvPr id="7" name="TextBox 6"/>
+          <p:cNvSpPr txBox="1"/>
+          <p:nvPr/>
+        </p:nvSpPr>
+        <p:spPr>
+          <a:xfrm>
+            <a:off x="640080" y="1463040"/>
+            <a:ext cx="10881360" cy="822960"/>
+          </a:xfrm>
+          <a:prstGeom prst="rect">
+            <a:avLst/>
+          </a:prstGeom>
+          <a:noFill/>
+        </p:spPr>
+        <p:txBody>
+          <a:bodyPr wrap="square" anchor="t" lIns="0" rIns="0" tIns="0" bIns="0">
+            <a:spAutoFit/>
+          </a:bodyPr>
+          <a:lstStyle/>
+          <a:p>
+            <a:pPr algn="l"/>
+            <a:r>
+              <a:rPr sz="1500" b="0" i="0">
+                <a:solidFill>
+                  <a:srgbClr val="1F2937"/>
+                </a:solidFill>
+                <a:latin typeface="Calibri"/>
+              </a:rPr>
+              <a:t>Recalibrated the entire pipeline — DES, surrogate, CP — on Department B (166,497 visits, roughly half A's volume, meaningfully different ESI acuity mix — a community rather than academic site) to test whether the core finding is specific to one department.</a:t>
+            </a:r>
+          </a:p>
+        </p:txBody>
+      </p:sp>
+      <p:graphicFrame>
+        <p:nvGraphicFramePr>
+          <p:cNvPr id="8" name="Table 7"/>
+          <p:cNvGraphicFramePr>
+            <a:graphicFrameLocks noGrp="1"/>
+          </p:cNvGraphicFramePr>
+          <p:nvPr/>
+        </p:nvGraphicFramePr>
+        <p:xfrm>
+          <a:off x="640080" y="2423160"/>
+          <a:ext cx="10881360" cy="1554480"/>
+        </p:xfrm>
+        <a:graphic>
+          <a:graphicData uri="http://schemas.openxmlformats.org/drawingml/2006/table">
+            <a:tbl>
+              <a:tblPr firstRow="1" bandRow="1">
+                <a:tableStyleId>{5C22544A-7EE6-4342-B048-85BDC9FD1C3A}</a:tableStyleId>
+              </a:tblPr>
+              <a:tblGrid>
+                <a:gridCol w="2743200"/>
+                <a:gridCol w="2926080"/>
+                <a:gridCol w="2286000"/>
+                <a:gridCol w="2926080"/>
+              </a:tblGrid>
+              <a:tr h="388620">
+                <a:tc>
+                  <a:txBody>
+                    <a:bodyPr/>
+                    <a:lstStyle/>
+                    <a:p>
+                      <a:pPr algn="l"/>
+                      <a:r>
+                        <a:rPr sz="1200" b="1">
+                          <a:solidFill>
+                            <a:srgbClr val="FFFFFF"/>
+                          </a:solidFill>
+                        </a:rPr>
+                        <a:t>Target</a:t>
+                      </a:r>
+                    </a:p>
+                  </a:txBody>
+                  <a:tcPr anchor="ctr" marT="50800" marB="50800">
+                    <a:solidFill>
+                      <a:srgbClr val="1E40AF"/>
+                    </a:solidFill>
+                  </a:tcPr>
+                </a:tc>
+                <a:tc>
+                  <a:txBody>
+                    <a:bodyPr/>
+                    <a:lstStyle/>
+                    <a:p>
+                      <a:pPr algn="ctr"/>
+                      <a:r>
+                        <a:rPr sz="1200" b="1">
+                          <a:solidFill>
+                            <a:srgbClr val="FFFFFF"/>
+                          </a:solidFill>
+                        </a:rPr>
+                        <a:t>Dept. B: pooled (worst category)</a:t>
+                      </a:r>
+                    </a:p>
+                  </a:txBody>
+                  <a:tcPr anchor="ctr" marT="50800" marB="50800">
+                    <a:solidFill>
+                      <a:srgbClr val="1E40AF"/>
+                    </a:solidFill>
+                  </a:tcPr>
+                </a:tc>
+                <a:tc>
+                  <a:txBody>
+                    <a:bodyPr/>
+                    <a:lstStyle/>
+                    <a:p>
+                      <a:pPr algn="ctr"/>
+                      <a:r>
+                        <a:rPr sz="1200" b="1">
+                          <a:solidFill>
+                            <a:srgbClr val="FFFFFF"/>
+                          </a:solidFill>
+                        </a:rPr>
+                        <a:t>Dept. B: Mondrian</a:t>
+                      </a:r>
+                    </a:p>
+                  </a:txBody>
+                  <a:tcPr anchor="ctr" marT="50800" marB="50800">
+                    <a:solidFill>
+                      <a:srgbClr val="1E40AF"/>
+                    </a:solidFill>
+                  </a:tcPr>
+                </a:tc>
+                <a:tc>
+                  <a:txBody>
+                    <a:bodyPr/>
+                    <a:lstStyle/>
+                    <a:p>
+                      <a:pPr algn="ctr"/>
+                      <a:r>
+                        <a:rPr sz="1200" b="1">
+                          <a:solidFill>
+                            <a:srgbClr val="FFFFFF"/>
+                          </a:solidFill>
+                        </a:rPr>
+                        <a:t>Dept. A (for comparison)</a:t>
+                      </a:r>
+                    </a:p>
+                  </a:txBody>
+                  <a:tcPr anchor="ctr" marT="50800" marB="50800">
+                    <a:solidFill>
+                      <a:srgbClr val="1E40AF"/>
+                    </a:solidFill>
+                  </a:tcPr>
+                </a:tc>
+              </a:tr>
+              <a:tr h="388620">
+                <a:tc>
+                  <a:txBody>
+                    <a:bodyPr/>
+                    <a:lstStyle/>
+                    <a:p>
+                      <a:pPr algn="l"/>
+                      <a:r>
+                        <a:rPr sz="1200">
+                          <a:solidFill>
+                            <a:srgbClr val="1F2937"/>
+                          </a:solidFill>
+                        </a:rPr>
+                        <a:t>mean_wait_minutes</a:t>
+                      </a:r>
+                    </a:p>
+                  </a:txBody>
+                  <a:tcPr anchor="ctr" marT="50800" marB="50800">
+                    <a:solidFill>
+                      <a:srgbClr val="F8FAFC"/>
+                    </a:solidFill>
+                  </a:tcPr>
+                </a:tc>
+                <a:tc>
+                  <a:txBody>
+                    <a:bodyPr/>
+                    <a:lstStyle/>
+                    <a:p>
+                      <a:pPr algn="ctr"/>
+                      <a:r>
+                        <a:rPr sz="1200">
+                          <a:solidFill>
+                            <a:srgbClr val="1F2937"/>
+                          </a:solidFill>
+                        </a:rPr>
+                        <a:t>76.2%</a:t>
+                      </a:r>
+                    </a:p>
+                  </a:txBody>
+                  <a:tcPr anchor="ctr" marT="50800" marB="50800">
+                    <a:solidFill>
+                      <a:srgbClr val="F8FAFC"/>
+                    </a:solidFill>
+                  </a:tcPr>
+                </a:tc>
+                <a:tc>
+                  <a:txBody>
+                    <a:bodyPr/>
+                    <a:lstStyle/>
+                    <a:p>
+                      <a:pPr algn="ctr"/>
+                      <a:r>
+                        <a:rPr sz="1200">
+                          <a:solidFill>
+                            <a:srgbClr val="1F2937"/>
+                          </a:solidFill>
+                        </a:rPr>
+                        <a:t>89.3%</a:t>
+                      </a:r>
+                    </a:p>
+                  </a:txBody>
+                  <a:tcPr anchor="ctr" marT="50800" marB="50800">
+                    <a:solidFill>
+                      <a:srgbClr val="F8FAFC"/>
+                    </a:solidFill>
+                  </a:tcPr>
+                </a:tc>
+                <a:tc>
+                  <a:txBody>
+                    <a:bodyPr/>
+                    <a:lstStyle/>
+                    <a:p>
+                      <a:pPr algn="ctr"/>
+                      <a:r>
+                        <a:rPr sz="1200">
+                          <a:solidFill>
+                            <a:srgbClr val="1F2937"/>
+                          </a:solidFill>
+                        </a:rPr>
+                        <a:t>68.2% -&gt; 90.9%</a:t>
+                      </a:r>
+                    </a:p>
+                  </a:txBody>
+                  <a:tcPr anchor="ctr" marT="50800" marB="50800">
+                    <a:solidFill>
+                      <a:srgbClr val="F8FAFC"/>
+                    </a:solidFill>
+                  </a:tcPr>
+                </a:tc>
+              </a:tr>
+              <a:tr h="388620">
+                <a:tc>
+                  <a:txBody>
+                    <a:bodyPr/>
+                    <a:lstStyle/>
+                    <a:p>
+                      <a:pPr algn="l"/>
+                      <a:r>
+                        <a:rPr sz="1200">
+                          <a:solidFill>
+                            <a:srgbClr val="1F2937"/>
+                          </a:solidFill>
+                        </a:rPr>
+                        <a:t>mean_total_minutes</a:t>
+                      </a:r>
+                    </a:p>
+                  </a:txBody>
+                  <a:tcPr anchor="ctr" marT="50800" marB="50800">
+                    <a:solidFill>
+                      <a:srgbClr val="FFFFFF"/>
+                    </a:solidFill>
+                  </a:tcPr>
+                </a:tc>
+                <a:tc>
+                  <a:txBody>
+                    <a:bodyPr/>
+                    <a:lstStyle/>
+                    <a:p>
+                      <a:pPr algn="ctr"/>
+                      <a:r>
+                        <a:rPr sz="1200">
+                          <a:solidFill>
+                            <a:srgbClr val="1F2937"/>
+                          </a:solidFill>
+                        </a:rPr>
+                        <a:t>81.0%</a:t>
+                      </a:r>
+                    </a:p>
+                  </a:txBody>
+                  <a:tcPr anchor="ctr" marT="50800" marB="50800">
+                    <a:solidFill>
+                      <a:srgbClr val="FFFFFF"/>
+                    </a:solidFill>
+                  </a:tcPr>
+                </a:tc>
+                <a:tc>
+                  <a:txBody>
+                    <a:bodyPr/>
+                    <a:lstStyle/>
+                    <a:p>
+                      <a:pPr algn="ctr"/>
+                      <a:r>
+                        <a:rPr sz="1200">
+                          <a:solidFill>
+                            <a:srgbClr val="1F2937"/>
+                          </a:solidFill>
+                        </a:rPr>
+                        <a:t>90.5%</a:t>
+                      </a:r>
+                    </a:p>
+                  </a:txBody>
+                  <a:tcPr anchor="ctr" marT="50800" marB="50800">
+                    <a:solidFill>
+                      <a:srgbClr val="FFFFFF"/>
+                    </a:solidFill>
+                  </a:tcPr>
+                </a:tc>
+                <a:tc>
+                  <a:txBody>
+                    <a:bodyPr/>
+                    <a:lstStyle/>
+                    <a:p>
+                      <a:pPr algn="ctr"/>
+                      <a:r>
+                        <a:rPr sz="1200">
+                          <a:solidFill>
+                            <a:srgbClr val="1F2937"/>
+                          </a:solidFill>
+                        </a:rPr>
+                        <a:t>80.7% -&gt; 92.0%</a:t>
+                      </a:r>
+                    </a:p>
+                  </a:txBody>
+                  <a:tcPr anchor="ctr" marT="50800" marB="50800">
+                    <a:solidFill>
+                      <a:srgbClr val="FFFFFF"/>
+                    </a:solidFill>
+                  </a:tcPr>
+                </a:tc>
+              </a:tr>
+              <a:tr h="388620">
+                <a:tc>
+                  <a:txBody>
+                    <a:bodyPr/>
+                    <a:lstStyle/>
+                    <a:p>
+                      <a:pPr algn="l"/>
+                      <a:r>
+                        <a:rPr sz="1200">
+                          <a:solidFill>
+                            <a:srgbClr val="1F2937"/>
+                          </a:solidFill>
+                        </a:rPr>
+                        <a:t>p95_wait_minutes</a:t>
+                      </a:r>
+                    </a:p>
+                  </a:txBody>
+                  <a:tcPr anchor="ctr" marT="50800" marB="50800">
+                    <a:solidFill>
+                      <a:srgbClr val="F8FAFC"/>
+                    </a:solidFill>
+                  </a:tcPr>
+                </a:tc>
+                <a:tc>
+                  <a:txBody>
+                    <a:bodyPr/>
+                    <a:lstStyle/>
+                    <a:p>
+                      <a:pPr algn="ctr"/>
+                      <a:r>
+                        <a:rPr sz="1200">
+                          <a:solidFill>
+                            <a:srgbClr val="1F2937"/>
+                          </a:solidFill>
+                        </a:rPr>
+                        <a:t>81.0%</a:t>
+                      </a:r>
+                    </a:p>
+                  </a:txBody>
+                  <a:tcPr anchor="ctr" marT="50800" marB="50800">
+                    <a:solidFill>
+                      <a:srgbClr val="F8FAFC"/>
+                    </a:solidFill>
+                  </a:tcPr>
+                </a:tc>
+                <a:tc>
+                  <a:txBody>
+                    <a:bodyPr/>
+                    <a:lstStyle/>
+                    <a:p>
+                      <a:pPr algn="ctr"/>
+                      <a:r>
+                        <a:rPr sz="1200">
+                          <a:solidFill>
+                            <a:srgbClr val="1F2937"/>
+                          </a:solidFill>
+                        </a:rPr>
+                        <a:t>86.9%</a:t>
+                      </a:r>
+                    </a:p>
+                  </a:txBody>
+                  <a:tcPr anchor="ctr" marT="50800" marB="50800">
+                    <a:solidFill>
+                      <a:srgbClr val="F8FAFC"/>
+                    </a:solidFill>
+                  </a:tcPr>
+                </a:tc>
+                <a:tc>
+                  <a:txBody>
+                    <a:bodyPr/>
+                    <a:lstStyle/>
+                    <a:p>
+                      <a:pPr algn="ctr"/>
+                      <a:r>
+                        <a:rPr sz="1200">
+                          <a:solidFill>
+                            <a:srgbClr val="1F2937"/>
+                          </a:solidFill>
+                        </a:rPr>
+                        <a:t>72.7% -&gt; 92.0%</a:t>
+                      </a:r>
+                    </a:p>
+                  </a:txBody>
+                  <a:tcPr anchor="ctr" marT="50800" marB="50800">
+                    <a:solidFill>
+                      <a:srgbClr val="F8FAFC"/>
+                    </a:solidFill>
+                  </a:tcPr>
+                </a:tc>
+              </a:tr>
+            </a:tbl>
+          </a:graphicData>
+        </a:graphic>
+      </p:graphicFrame>
+      <p:sp>
+        <p:nvSpPr>
+          <p:cNvPr id="9" name="Rectangle 8"/>
+          <p:cNvSpPr/>
+          <p:nvPr/>
+        </p:nvSpPr>
+        <p:spPr>
+          <a:xfrm>
+            <a:off x="640080" y="4251960"/>
+            <a:ext cx="10881360" cy="2194560"/>
+          </a:xfrm>
+          <a:prstGeom prst="rect">
+            <a:avLst/>
+          </a:prstGeom>
+          <a:solidFill>
+            <a:srgbClr val="F8FAFC"/>
+          </a:solidFill>
+          <a:ln w="9525">
+            <a:solidFill>
+              <a:srgbClr val="E2E8F0"/>
+            </a:solidFill>
+          </a:ln>
+          <a:effectLst/>
+        </p:spPr>
+        <p:style>
+          <a:lnRef idx="1">
+            <a:schemeClr val="accent1"/>
+          </a:lnRef>
+          <a:fillRef idx="3">
+            <a:schemeClr val="accent1"/>
+          </a:fillRef>
+          <a:effectRef idx="2">
+            <a:schemeClr val="accent1"/>
+          </a:effectRef>
+          <a:fontRef idx="minor">
+            <a:schemeClr val="lt1"/>
+          </a:fontRef>
+        </p:style>
+        <p:txBody>
+          <a:bodyPr rtlCol="0" anchor="ctr"/>
+          <a:lstStyle/>
+          <a:p>
+            <a:pPr algn="ctr"/>
+          </a:p>
+        </p:txBody>
+      </p:sp>
+      <p:sp>
+        <p:nvSpPr>
+          <p:cNvPr id="10" name="TextBox 9"/>
+          <p:cNvSpPr txBox="1"/>
+          <p:nvPr/>
+        </p:nvSpPr>
+        <p:spPr>
+          <a:xfrm>
+            <a:off x="914400" y="4389120"/>
+            <a:ext cx="10332720" cy="1965960"/>
+          </a:xfrm>
+          <a:prstGeom prst="rect">
+            <a:avLst/>
+          </a:prstGeom>
+          <a:noFill/>
+        </p:spPr>
+        <p:txBody>
+          <a:bodyPr wrap="square" anchor="t" lIns="0" rIns="0" tIns="0" bIns="0">
+            <a:spAutoFit/>
+          </a:bodyPr>
+          <a:lstStyle/>
+          <a:p>
+            <a:pPr algn="l"/>
+            <a:r>
+              <a:rPr sz="1300" b="0" i="0">
+                <a:solidFill>
+                  <a:srgbClr val="1F2937"/>
+                </a:solidFill>
+                <a:latin typeface="Calibri"/>
+              </a:rPr>
+              <a:t>Same worst category (understaffed + high demand) in both independent sites, similar correction magnitude from Mondrian CP, same wasted-width pattern on the easy category. Honest difference worth keeping: n_patients behaves differently between sites — a real conditional gap appears in Department B that wasn't present in A, and Mondrian helps there this time. That's disclosed, not smoothed over — and it's part of what makes the replication credible rather than suspiciously perfect.</a:t>
+            </a:r>
+          </a:p>
+        </p:txBody>
+      </p:sp>
+    </p:spTree>
+  </p:cSld>
+  <p:clrMapOvr>
+    <a:masterClrMapping/>
+  </p:clrMapOvr>
+</p:sld>
+</file>
+
+<file path=ppt/slides/slide19.xml><?xml version="1.0" encoding="utf-8"?>
+<p:sld xmlns:a="http://schemas.openxmlformats.org/drawingml/2006/main" xmlns:p="http://schemas.openxmlformats.org/presentationml/2006/main" xmlns:r="http://schemas.openxmlformats.org/officeDocument/2006/relationships">
+  <p:cSld>
+    <p:spTree>
+      <p:nvGrpSpPr>
+        <p:cNvPr id="1" name=""/>
+        <p:cNvGrpSpPr/>
+        <p:nvPr/>
+      </p:nvGrpSpPr>
+      <p:grpSpPr/>
+      <p:sp>
+        <p:nvSpPr>
+          <p:cNvPr id="2" name="Rectangle 1"/>
+          <p:cNvSpPr/>
+          <p:nvPr/>
+        </p:nvSpPr>
+        <p:spPr>
+          <a:xfrm>
+            <a:off x="0" y="0"/>
+            <a:ext cx="12191695" cy="82296"/>
+          </a:xfrm>
+          <a:prstGeom prst="rect">
+            <a:avLst/>
+          </a:prstGeom>
+          <a:solidFill>
+            <a:srgbClr val="3B82F6"/>
+          </a:solidFill>
+          <a:ln>
+            <a:noFill/>
+          </a:ln>
+          <a:effectLst/>
+        </p:spPr>
+        <p:style>
+          <a:lnRef idx="1">
+            <a:schemeClr val="accent1"/>
+          </a:lnRef>
+          <a:fillRef idx="3">
+            <a:schemeClr val="accent1"/>
+          </a:fillRef>
+          <a:effectRef idx="2">
+            <a:schemeClr val="accent1"/>
+          </a:effectRef>
+          <a:fontRef idx="minor">
+            <a:schemeClr val="lt1"/>
+          </a:fontRef>
+        </p:style>
+        <p:txBody>
+          <a:bodyPr rtlCol="0" anchor="ctr"/>
+          <a:lstStyle/>
+          <a:p>
+            <a:pPr algn="ctr"/>
+          </a:p>
+        </p:txBody>
+      </p:sp>
+      <p:sp>
+        <p:nvSpPr>
+          <p:cNvPr id="3" name="TextBox 2"/>
+          <p:cNvSpPr txBox="1"/>
+          <p:nvPr/>
+        </p:nvSpPr>
+        <p:spPr>
+          <a:xfrm>
+            <a:off x="548640" y="274320"/>
+            <a:ext cx="10515600" cy="320040"/>
+          </a:xfrm>
+          <a:prstGeom prst="rect">
+            <a:avLst/>
+          </a:prstGeom>
+          <a:noFill/>
+        </p:spPr>
+        <p:txBody>
+          <a:bodyPr wrap="square" anchor="t" lIns="0" rIns="0" tIns="0" bIns="0">
+            <a:spAutoFit/>
+          </a:bodyPr>
+          <a:lstStyle/>
+          <a:p>
+            <a:pPr algn="l"/>
+            <a:r>
+              <a:rPr sz="1300" b="1" i="0">
+                <a:solidFill>
+                  <a:srgbClr val="3B82F6"/>
+                </a:solidFill>
+                <a:latin typeface="Calibri"/>
+              </a:rPr>
+              <a:t>SUMMARY</a:t>
+            </a:r>
+          </a:p>
+        </p:txBody>
+      </p:sp>
+      <p:sp>
+        <p:nvSpPr>
+          <p:cNvPr id="4" name="TextBox 3"/>
+          <p:cNvSpPr txBox="1"/>
+          <p:nvPr/>
+        </p:nvSpPr>
+        <p:spPr>
+          <a:xfrm>
+            <a:off x="548640" y="566928"/>
+            <a:ext cx="10881360" cy="640080"/>
+          </a:xfrm>
+          <a:prstGeom prst="rect">
+            <a:avLst/>
+          </a:prstGeom>
+          <a:noFill/>
+        </p:spPr>
+        <p:txBody>
+          <a:bodyPr wrap="square" anchor="t" lIns="0" rIns="0" tIns="0" bIns="0">
+            <a:spAutoFit/>
+          </a:bodyPr>
+          <a:lstStyle/>
+          <a:p>
+            <a:pPr algn="l"/>
+            <a:r>
+              <a:rPr sz="2600" b="1" i="0">
+                <a:solidFill>
+                  <a:srgbClr val="1B2238"/>
+                </a:solidFill>
+                <a:latin typeface="Calibri"/>
+              </a:rPr>
+              <a:t>What We Accomplished</a:t>
+            </a:r>
+          </a:p>
+        </p:txBody>
+      </p:sp>
+      <p:sp>
+        <p:nvSpPr>
+          <p:cNvPr id="5" name="Rectangle 4"/>
+          <p:cNvSpPr/>
+          <p:nvPr/>
+        </p:nvSpPr>
+        <p:spPr>
+          <a:xfrm>
+            <a:off x="548640" y="1170432"/>
+            <a:ext cx="1005840" cy="38100"/>
+          </a:xfrm>
+          <a:prstGeom prst="rect">
+            <a:avLst/>
+          </a:prstGeom>
+          <a:solidFill>
+            <a:srgbClr val="3B82F6"/>
+          </a:solidFill>
+          <a:ln>
+            <a:noFill/>
+          </a:ln>
+          <a:effectLst/>
+        </p:spPr>
+        <p:style>
+          <a:lnRef idx="1">
+            <a:schemeClr val="accent1"/>
+          </a:lnRef>
+          <a:fillRef idx="3">
+            <a:schemeClr val="accent1"/>
+          </a:fillRef>
+          <a:effectRef idx="2">
+            <a:schemeClr val="accent1"/>
+          </a:effectRef>
+          <a:fontRef idx="minor">
+            <a:schemeClr val="lt1"/>
+          </a:fontRef>
+        </p:style>
+        <p:txBody>
+          <a:bodyPr rtlCol="0" anchor="ctr"/>
+          <a:lstStyle/>
+          <a:p>
+            <a:pPr algn="ctr"/>
+          </a:p>
+        </p:txBody>
+      </p:sp>
+      <p:sp>
+        <p:nvSpPr>
+          <p:cNvPr id="6" name="TextBox 5"/>
+          <p:cNvSpPr txBox="1"/>
+          <p:nvPr/>
+        </p:nvSpPr>
+        <p:spPr>
+          <a:xfrm>
+            <a:off x="11155680" y="6446520"/>
+            <a:ext cx="822960" cy="320040"/>
+          </a:xfrm>
+          <a:prstGeom prst="rect">
+            <a:avLst/>
+          </a:prstGeom>
+          <a:noFill/>
+        </p:spPr>
+        <p:txBody>
+          <a:bodyPr wrap="square" anchor="t" lIns="0" rIns="0" tIns="0" bIns="0">
+            <a:spAutoFit/>
+          </a:bodyPr>
+          <a:lstStyle/>
+          <a:p>
+            <a:pPr algn="r"/>
+            <a:r>
+              <a:rPr sz="1100" b="0" i="0">
+                <a:solidFill>
+                  <a:srgbClr val="6B7280"/>
+                </a:solidFill>
+                <a:latin typeface="Calibri"/>
+              </a:rPr>
+              <a:t>19 / 21</a:t>
             </a:r>
           </a:p>
         </p:txBody>
@@ -7196,81 +9922,97 @@
           <a:p>
             <a:pPr>
               <a:spcAft>
-                <a:spcPts val="1600"/>
+                <a:spcPts val="1100"/>
               </a:spcAft>
             </a:pPr>
             <a:r>
-              <a:rPr sz="1700">
+              <a:rPr sz="1500">
                 <a:solidFill>
                   <a:srgbClr val="1F2937"/>
                 </a:solidFill>
                 <a:latin typeface="Calibri"/>
               </a:rPr>
-              <a:t>•  Service/treatment time is literature-calibrated, not derived from the dataset — the dataset has no discharge timestamp. Disclosed explicitly throughout, not blended silently into the "real data" story.</a:t>
+              <a:t>•  Built and validated an ER discrete-event simulation (SimPy) calibrated on real hospital arrival data — 91.0% match to real daily patient volume.</a:t>
             </a:r>
           </a:p>
           <a:p>
             <a:pPr>
               <a:spcAft>
-                <a:spcPts val="1600"/>
+                <a:spcPts val="1100"/>
               </a:spcAft>
             </a:pPr>
             <a:r>
-              <a:rPr sz="1700">
+              <a:rPr sz="1500">
                 <a:solidFill>
                   <a:srgbClr val="1F2937"/>
                 </a:solidFill>
                 <a:latin typeface="Calibri"/>
               </a:rPr>
-              <a:t>•  Calibrated on one department (the largest/academic site) of one health system — generalization to other hospitals or EDs is untested.</a:t>
+              <a:t>•  Generated a 5000-scenario training sweep and trained a surrogate model with strong accuracy on 3 of 4 targets (R² 0.76–0.93).</a:t>
             </a:r>
           </a:p>
           <a:p>
             <a:pPr>
               <a:spcAft>
-                <a:spcPts val="1600"/>
+                <a:spcPts val="1100"/>
               </a:spcAft>
             </a:pPr>
             <a:r>
-              <a:rPr sz="1700">
+              <a:rPr sz="1500">
                 <a:solidFill>
                   <a:srgbClr val="1F2937"/>
                 </a:solidFill>
                 <a:latin typeface="Calibri"/>
               </a:rPr>
-              <a:t>•  The exchangeability breakdown is partly a surrogate-model artifact (tree-based extrapolation), not purely a CP phenomenon — a different surrogate architecture might behave differently OOD.</a:t>
+              <a:t>•  Implemented and compared 5 UQ methods — GP baseline, standard CP, Mondrian CP, CQR, and Mondrian CQR — all on the same test data and target coverage.</a:t>
             </a:r>
           </a:p>
           <a:p>
             <a:pPr>
               <a:spcAft>
-                <a:spcPts val="1600"/>
+                <a:spcPts val="1100"/>
               </a:spcAft>
             </a:pPr>
             <a:r>
-              <a:rPr sz="1700">
+              <a:rPr sz="1500">
                 <a:solidFill>
                   <a:srgbClr val="1F2937"/>
                 </a:solidFill>
                 <a:latin typeface="Calibri"/>
               </a:rPr>
-              <a:t>•  Literature review (30 papers, 3 in depth) still in progress.</a:t>
+              <a:t>•  Demonstrated Mondrian CP closing a real marginal-vs-conditional coverage gap (68–81% pooled coverage in the hardest category, corrected to 91–92%), validated with paired significance tests (p &lt; 0.001) across 30 independent repeats, not a single lucky split.</a:t>
             </a:r>
           </a:p>
           <a:p>
             <a:pPr>
               <a:spcAft>
-                <a:spcPts val="1600"/>
+                <a:spcPts val="1100"/>
               </a:spcAft>
             </a:pPr>
             <a:r>
-              <a:rPr sz="1700">
+              <a:rPr sz="1500">
                 <a:solidFill>
                   <a:srgbClr val="1F2937"/>
                 </a:solidFill>
                 <a:latin typeface="Calibri"/>
               </a:rPr>
-              <a:t>•  This is a working results deck, not the final end-sem PPT — that will follow the instructor's specific guidelines once shared.</a:t>
+              <a:t>•  Ran an exchangeability stress test across 8 severity levels with two structurally different surrogate architectures, and root-caused the coverage collapse to a specific, verified mechanism in each case, not just "it broke."</a:t>
+            </a:r>
+          </a:p>
+          <a:p>
+            <a:pPr>
+              <a:spcAft>
+                <a:spcPts val="1100"/>
+              </a:spcAft>
+            </a:pPr>
+            <a:r>
+              <a:rPr sz="1500">
+                <a:solidFill>
+                  <a:srgbClr val="1F2937"/>
+                </a:solidFill>
+                <a:latin typeface="Calibri"/>
+              </a:rPr>
+              <a:t>•  Replicated the core finding at a second, independent department with different volume and acuity mix — the marginal-vs-conditional gap Mondrian CP closes is not a one-site artifact.</a:t>
             </a:r>
           </a:p>
         </p:txBody>
@@ -7481,7 +10223,7 @@
                 </a:solidFill>
                 <a:latin typeface="Calibri"/>
               </a:rPr>
-              <a:t>2 / 16</a:t>
+              <a:t>2 / 21</a:t>
             </a:r>
           </a:p>
         </p:txBody>
@@ -7569,6 +10311,702 @@
                 <a:latin typeface="Calibri"/>
               </a:rPr>
               <a:t>•  Conformal Prediction (CP) is distribution-free with a finite-sample coverage guarantee and is cheap to calibrate - but it's only been validated for surrogate models in a narrow set of domains so far.</a:t>
+            </a:r>
+          </a:p>
+        </p:txBody>
+      </p:sp>
+    </p:spTree>
+  </p:cSld>
+  <p:clrMapOvr>
+    <a:masterClrMapping/>
+  </p:clrMapOvr>
+</p:sld>
+</file>
+
+<file path=ppt/slides/slide20.xml><?xml version="1.0" encoding="utf-8"?>
+<p:sld xmlns:a="http://schemas.openxmlformats.org/drawingml/2006/main" xmlns:p="http://schemas.openxmlformats.org/presentationml/2006/main" xmlns:r="http://schemas.openxmlformats.org/officeDocument/2006/relationships">
+  <p:cSld>
+    <p:spTree>
+      <p:nvGrpSpPr>
+        <p:cNvPr id="1" name=""/>
+        <p:cNvGrpSpPr/>
+        <p:nvPr/>
+      </p:nvGrpSpPr>
+      <p:grpSpPr/>
+      <p:sp>
+        <p:nvSpPr>
+          <p:cNvPr id="2" name="Rectangle 1"/>
+          <p:cNvSpPr/>
+          <p:nvPr/>
+        </p:nvSpPr>
+        <p:spPr>
+          <a:xfrm>
+            <a:off x="0" y="0"/>
+            <a:ext cx="12191695" cy="82296"/>
+          </a:xfrm>
+          <a:prstGeom prst="rect">
+            <a:avLst/>
+          </a:prstGeom>
+          <a:solidFill>
+            <a:srgbClr val="3B82F6"/>
+          </a:solidFill>
+          <a:ln>
+            <a:noFill/>
+          </a:ln>
+          <a:effectLst/>
+        </p:spPr>
+        <p:style>
+          <a:lnRef idx="1">
+            <a:schemeClr val="accent1"/>
+          </a:lnRef>
+          <a:fillRef idx="3">
+            <a:schemeClr val="accent1"/>
+          </a:fillRef>
+          <a:effectRef idx="2">
+            <a:schemeClr val="accent1"/>
+          </a:effectRef>
+          <a:fontRef idx="minor">
+            <a:schemeClr val="lt1"/>
+          </a:fontRef>
+        </p:style>
+        <p:txBody>
+          <a:bodyPr rtlCol="0" anchor="ctr"/>
+          <a:lstStyle/>
+          <a:p>
+            <a:pPr algn="ctr"/>
+          </a:p>
+        </p:txBody>
+      </p:sp>
+      <p:sp>
+        <p:nvSpPr>
+          <p:cNvPr id="3" name="TextBox 2"/>
+          <p:cNvSpPr txBox="1"/>
+          <p:nvPr/>
+        </p:nvSpPr>
+        <p:spPr>
+          <a:xfrm>
+            <a:off x="548640" y="274320"/>
+            <a:ext cx="10515600" cy="320040"/>
+          </a:xfrm>
+          <a:prstGeom prst="rect">
+            <a:avLst/>
+          </a:prstGeom>
+          <a:noFill/>
+        </p:spPr>
+        <p:txBody>
+          <a:bodyPr wrap="square" anchor="t" lIns="0" rIns="0" tIns="0" bIns="0">
+            <a:spAutoFit/>
+          </a:bodyPr>
+          <a:lstStyle/>
+          <a:p>
+            <a:pPr algn="l"/>
+            <a:r>
+              <a:rPr sz="1300" b="1" i="0">
+                <a:solidFill>
+                  <a:srgbClr val="3B82F6"/>
+                </a:solidFill>
+                <a:latin typeface="Calibri"/>
+              </a:rPr>
+              <a:t>VERDICT</a:t>
+            </a:r>
+          </a:p>
+        </p:txBody>
+      </p:sp>
+      <p:sp>
+        <p:nvSpPr>
+          <p:cNvPr id="4" name="TextBox 3"/>
+          <p:cNvSpPr txBox="1"/>
+          <p:nvPr/>
+        </p:nvSpPr>
+        <p:spPr>
+          <a:xfrm>
+            <a:off x="548640" y="566928"/>
+            <a:ext cx="10881360" cy="640080"/>
+          </a:xfrm>
+          <a:prstGeom prst="rect">
+            <a:avLst/>
+          </a:prstGeom>
+          <a:noFill/>
+        </p:spPr>
+        <p:txBody>
+          <a:bodyPr wrap="square" anchor="t" lIns="0" rIns="0" tIns="0" bIns="0">
+            <a:spAutoFit/>
+          </a:bodyPr>
+          <a:lstStyle/>
+          <a:p>
+            <a:pPr algn="l"/>
+            <a:r>
+              <a:rPr sz="2400" b="1" i="0">
+                <a:solidFill>
+                  <a:srgbClr val="1B2238"/>
+                </a:solidFill>
+                <a:latin typeface="Calibri"/>
+              </a:rPr>
+              <a:t>Did We Meet Our Novelty Target?</a:t>
+            </a:r>
+          </a:p>
+        </p:txBody>
+      </p:sp>
+      <p:sp>
+        <p:nvSpPr>
+          <p:cNvPr id="5" name="Rectangle 4"/>
+          <p:cNvSpPr/>
+          <p:nvPr/>
+        </p:nvSpPr>
+        <p:spPr>
+          <a:xfrm>
+            <a:off x="548640" y="1170432"/>
+            <a:ext cx="1005840" cy="38100"/>
+          </a:xfrm>
+          <a:prstGeom prst="rect">
+            <a:avLst/>
+          </a:prstGeom>
+          <a:solidFill>
+            <a:srgbClr val="3B82F6"/>
+          </a:solidFill>
+          <a:ln>
+            <a:noFill/>
+          </a:ln>
+          <a:effectLst/>
+        </p:spPr>
+        <p:style>
+          <a:lnRef idx="1">
+            <a:schemeClr val="accent1"/>
+          </a:lnRef>
+          <a:fillRef idx="3">
+            <a:schemeClr val="accent1"/>
+          </a:fillRef>
+          <a:effectRef idx="2">
+            <a:schemeClr val="accent1"/>
+          </a:effectRef>
+          <a:fontRef idx="minor">
+            <a:schemeClr val="lt1"/>
+          </a:fontRef>
+        </p:style>
+        <p:txBody>
+          <a:bodyPr rtlCol="0" anchor="ctr"/>
+          <a:lstStyle/>
+          <a:p>
+            <a:pPr algn="ctr"/>
+          </a:p>
+        </p:txBody>
+      </p:sp>
+      <p:sp>
+        <p:nvSpPr>
+          <p:cNvPr id="6" name="TextBox 5"/>
+          <p:cNvSpPr txBox="1"/>
+          <p:nvPr/>
+        </p:nvSpPr>
+        <p:spPr>
+          <a:xfrm>
+            <a:off x="11155680" y="6446520"/>
+            <a:ext cx="822960" cy="320040"/>
+          </a:xfrm>
+          <a:prstGeom prst="rect">
+            <a:avLst/>
+          </a:prstGeom>
+          <a:noFill/>
+        </p:spPr>
+        <p:txBody>
+          <a:bodyPr wrap="square" anchor="t" lIns="0" rIns="0" tIns="0" bIns="0">
+            <a:spAutoFit/>
+          </a:bodyPr>
+          <a:lstStyle/>
+          <a:p>
+            <a:pPr algn="r"/>
+            <a:r>
+              <a:rPr sz="1100" b="0" i="0">
+                <a:solidFill>
+                  <a:srgbClr val="6B7280"/>
+                </a:solidFill>
+                <a:latin typeface="Calibri"/>
+              </a:rPr>
+              <a:t>20 / 21</a:t>
+            </a:r>
+          </a:p>
+        </p:txBody>
+      </p:sp>
+      <p:sp>
+        <p:nvSpPr>
+          <p:cNvPr id="7" name="TextBox 6"/>
+          <p:cNvSpPr txBox="1"/>
+          <p:nvPr/>
+        </p:nvSpPr>
+        <p:spPr>
+          <a:xfrm>
+            <a:off x="640080" y="1554480"/>
+            <a:ext cx="10881360" cy="1005840"/>
+          </a:xfrm>
+          <a:prstGeom prst="rect">
+            <a:avLst/>
+          </a:prstGeom>
+          <a:noFill/>
+        </p:spPr>
+        <p:txBody>
+          <a:bodyPr wrap="square" anchor="t" lIns="0" rIns="0" tIns="0" bIns="0">
+            <a:spAutoFit/>
+          </a:bodyPr>
+          <a:lstStyle/>
+          <a:p>
+            <a:pPr algn="l"/>
+            <a:r>
+              <a:rPr sz="1600" b="0" i="0">
+                <a:solidFill>
+                  <a:srgbClr val="1F2937"/>
+                </a:solidFill>
+                <a:latin typeface="Calibri"/>
+              </a:rPr>
+              <a:t>The claim was to test Gopakumar et al. (2026)'s two stated CP limitations — marginal coverage, exchangeability — outside the physics domains they validated CP in, using a discrete-event / queueing simulation surrogate instead.</a:t>
+            </a:r>
+          </a:p>
+        </p:txBody>
+      </p:sp>
+      <p:sp>
+        <p:nvSpPr>
+          <p:cNvPr id="8" name="Rectangle 7"/>
+          <p:cNvSpPr/>
+          <p:nvPr/>
+        </p:nvSpPr>
+        <p:spPr>
+          <a:xfrm>
+            <a:off x="640080" y="2743200"/>
+            <a:ext cx="10881360" cy="2286000"/>
+          </a:xfrm>
+          <a:prstGeom prst="rect">
+            <a:avLst/>
+          </a:prstGeom>
+          <a:solidFill>
+            <a:srgbClr val="F8FAFC"/>
+          </a:solidFill>
+          <a:ln w="9525">
+            <a:solidFill>
+              <a:srgbClr val="E2E8F0"/>
+            </a:solidFill>
+          </a:ln>
+          <a:effectLst/>
+        </p:spPr>
+        <p:style>
+          <a:lnRef idx="1">
+            <a:schemeClr val="accent1"/>
+          </a:lnRef>
+          <a:fillRef idx="3">
+            <a:schemeClr val="accent1"/>
+          </a:fillRef>
+          <a:effectRef idx="2">
+            <a:schemeClr val="accent1"/>
+          </a:effectRef>
+          <a:fontRef idx="minor">
+            <a:schemeClr val="lt1"/>
+          </a:fontRef>
+        </p:style>
+        <p:txBody>
+          <a:bodyPr rtlCol="0" anchor="ctr"/>
+          <a:lstStyle/>
+          <a:p>
+            <a:pPr algn="ctr"/>
+          </a:p>
+        </p:txBody>
+      </p:sp>
+      <p:sp>
+        <p:nvSpPr>
+          <p:cNvPr id="9" name="TextBox 8"/>
+          <p:cNvSpPr txBox="1"/>
+          <p:nvPr/>
+        </p:nvSpPr>
+        <p:spPr>
+          <a:xfrm>
+            <a:off x="914400" y="2926080"/>
+            <a:ext cx="10332720" cy="2011680"/>
+          </a:xfrm>
+          <a:prstGeom prst="rect">
+            <a:avLst/>
+          </a:prstGeom>
+          <a:noFill/>
+        </p:spPr>
+        <p:txBody>
+          <a:bodyPr wrap="square">
+            <a:spAutoFit/>
+          </a:bodyPr>
+          <a:lstStyle/>
+          <a:p>
+            <a:pPr>
+              <a:spcAft>
+                <a:spcPts val="1000"/>
+              </a:spcAft>
+            </a:pPr>
+            <a:r>
+              <a:rPr sz="1500">
+                <a:solidFill>
+                  <a:srgbClr val="1F2937"/>
+                </a:solidFill>
+                <a:latin typeface="Calibri"/>
+              </a:rPr>
+              <a:t>•  Marginal coverage limitation: tested, and now statistically validated (p &lt; 0.001, 30 repeats) and replicated at a second, independent site.</a:t>
+            </a:r>
+          </a:p>
+          <a:p>
+            <a:pPr>
+              <a:spcAft>
+                <a:spcPts val="1000"/>
+              </a:spcAft>
+            </a:pPr>
+            <a:r>
+              <a:rPr sz="1500">
+                <a:solidFill>
+                  <a:srgbClr val="1F2937"/>
+                </a:solidFill>
+                <a:latin typeface="Calibri"/>
+              </a:rPr>
+              <a:t>•  Exchangeability limitation: tested with two structurally different surrogate architectures — confirmed to break down outside the training distribution regardless of architecture, with a specific, verified root cause in each case rather than a generic "performance degrades" claim.</a:t>
+            </a:r>
+          </a:p>
+        </p:txBody>
+      </p:sp>
+      <p:sp>
+        <p:nvSpPr>
+          <p:cNvPr id="10" name="TextBox 9"/>
+          <p:cNvSpPr txBox="1"/>
+          <p:nvPr/>
+        </p:nvSpPr>
+        <p:spPr>
+          <a:xfrm>
+            <a:off x="640080" y="5257800"/>
+            <a:ext cx="10881360" cy="1097280"/>
+          </a:xfrm>
+          <a:prstGeom prst="rect">
+            <a:avLst/>
+          </a:prstGeom>
+          <a:noFill/>
+        </p:spPr>
+        <p:txBody>
+          <a:bodyPr wrap="square" anchor="t" lIns="0" rIns="0" tIns="0" bIns="0">
+            <a:spAutoFit/>
+          </a:bodyPr>
+          <a:lstStyle/>
+          <a:p>
+            <a:pPr algn="l"/>
+            <a:r>
+              <a:rPr sz="1600" b="1" i="0">
+                <a:solidFill>
+                  <a:srgbClr val="16A34A"/>
+                </a:solidFill>
+                <a:latin typeface="Calibri"/>
+              </a:rPr>
+              <a:t>Yes — both limitations were tested in a domain they hadn't been tested in before, with concrete, statistically validated, cross-architecture and cross-site answers, not just a single replication of the base paper's physics-domain results.</a:t>
+            </a:r>
+          </a:p>
+        </p:txBody>
+      </p:sp>
+    </p:spTree>
+  </p:cSld>
+  <p:clrMapOvr>
+    <a:masterClrMapping/>
+  </p:clrMapOvr>
+</p:sld>
+</file>
+
+<file path=ppt/slides/slide21.xml><?xml version="1.0" encoding="utf-8"?>
+<p:sld xmlns:a="http://schemas.openxmlformats.org/drawingml/2006/main" xmlns:p="http://schemas.openxmlformats.org/presentationml/2006/main" xmlns:r="http://schemas.openxmlformats.org/officeDocument/2006/relationships">
+  <p:cSld>
+    <p:spTree>
+      <p:nvGrpSpPr>
+        <p:cNvPr id="1" name=""/>
+        <p:cNvGrpSpPr/>
+        <p:nvPr/>
+      </p:nvGrpSpPr>
+      <p:grpSpPr/>
+      <p:sp>
+        <p:nvSpPr>
+          <p:cNvPr id="2" name="Rectangle 1"/>
+          <p:cNvSpPr/>
+          <p:nvPr/>
+        </p:nvSpPr>
+        <p:spPr>
+          <a:xfrm>
+            <a:off x="0" y="0"/>
+            <a:ext cx="12191695" cy="82296"/>
+          </a:xfrm>
+          <a:prstGeom prst="rect">
+            <a:avLst/>
+          </a:prstGeom>
+          <a:solidFill>
+            <a:srgbClr val="3B82F6"/>
+          </a:solidFill>
+          <a:ln>
+            <a:noFill/>
+          </a:ln>
+          <a:effectLst/>
+        </p:spPr>
+        <p:style>
+          <a:lnRef idx="1">
+            <a:schemeClr val="accent1"/>
+          </a:lnRef>
+          <a:fillRef idx="3">
+            <a:schemeClr val="accent1"/>
+          </a:fillRef>
+          <a:effectRef idx="2">
+            <a:schemeClr val="accent1"/>
+          </a:effectRef>
+          <a:fontRef idx="minor">
+            <a:schemeClr val="lt1"/>
+          </a:fontRef>
+        </p:style>
+        <p:txBody>
+          <a:bodyPr rtlCol="0" anchor="ctr"/>
+          <a:lstStyle/>
+          <a:p>
+            <a:pPr algn="ctr"/>
+          </a:p>
+        </p:txBody>
+      </p:sp>
+      <p:sp>
+        <p:nvSpPr>
+          <p:cNvPr id="3" name="TextBox 2"/>
+          <p:cNvSpPr txBox="1"/>
+          <p:nvPr/>
+        </p:nvSpPr>
+        <p:spPr>
+          <a:xfrm>
+            <a:off x="548640" y="274320"/>
+            <a:ext cx="10515600" cy="320040"/>
+          </a:xfrm>
+          <a:prstGeom prst="rect">
+            <a:avLst/>
+          </a:prstGeom>
+          <a:noFill/>
+        </p:spPr>
+        <p:txBody>
+          <a:bodyPr wrap="square" anchor="t" lIns="0" rIns="0" tIns="0" bIns="0">
+            <a:spAutoFit/>
+          </a:bodyPr>
+          <a:lstStyle/>
+          <a:p>
+            <a:pPr algn="l"/>
+            <a:r>
+              <a:rPr sz="1300" b="1" i="0">
+                <a:solidFill>
+                  <a:srgbClr val="3B82F6"/>
+                </a:solidFill>
+                <a:latin typeface="Calibri"/>
+              </a:rPr>
+              <a:t>HONESTY CHECK</a:t>
+            </a:r>
+          </a:p>
+        </p:txBody>
+      </p:sp>
+      <p:sp>
+        <p:nvSpPr>
+          <p:cNvPr id="4" name="TextBox 3"/>
+          <p:cNvSpPr txBox="1"/>
+          <p:nvPr/>
+        </p:nvSpPr>
+        <p:spPr>
+          <a:xfrm>
+            <a:off x="548640" y="566928"/>
+            <a:ext cx="10881360" cy="640080"/>
+          </a:xfrm>
+          <a:prstGeom prst="rect">
+            <a:avLst/>
+          </a:prstGeom>
+          <a:noFill/>
+        </p:spPr>
+        <p:txBody>
+          <a:bodyPr wrap="square" anchor="t" lIns="0" rIns="0" tIns="0" bIns="0">
+            <a:spAutoFit/>
+          </a:bodyPr>
+          <a:lstStyle/>
+          <a:p>
+            <a:pPr algn="l"/>
+            <a:r>
+              <a:rPr sz="2600" b="1" i="0">
+                <a:solidFill>
+                  <a:srgbClr val="1B2238"/>
+                </a:solidFill>
+                <a:latin typeface="Calibri"/>
+              </a:rPr>
+              <a:t>Limitations &amp; What's Left</a:t>
+            </a:r>
+          </a:p>
+        </p:txBody>
+      </p:sp>
+      <p:sp>
+        <p:nvSpPr>
+          <p:cNvPr id="5" name="Rectangle 4"/>
+          <p:cNvSpPr/>
+          <p:nvPr/>
+        </p:nvSpPr>
+        <p:spPr>
+          <a:xfrm>
+            <a:off x="548640" y="1170432"/>
+            <a:ext cx="1005840" cy="38100"/>
+          </a:xfrm>
+          <a:prstGeom prst="rect">
+            <a:avLst/>
+          </a:prstGeom>
+          <a:solidFill>
+            <a:srgbClr val="3B82F6"/>
+          </a:solidFill>
+          <a:ln>
+            <a:noFill/>
+          </a:ln>
+          <a:effectLst/>
+        </p:spPr>
+        <p:style>
+          <a:lnRef idx="1">
+            <a:schemeClr val="accent1"/>
+          </a:lnRef>
+          <a:fillRef idx="3">
+            <a:schemeClr val="accent1"/>
+          </a:fillRef>
+          <a:effectRef idx="2">
+            <a:schemeClr val="accent1"/>
+          </a:effectRef>
+          <a:fontRef idx="minor">
+            <a:schemeClr val="lt1"/>
+          </a:fontRef>
+        </p:style>
+        <p:txBody>
+          <a:bodyPr rtlCol="0" anchor="ctr"/>
+          <a:lstStyle/>
+          <a:p>
+            <a:pPr algn="ctr"/>
+          </a:p>
+        </p:txBody>
+      </p:sp>
+      <p:sp>
+        <p:nvSpPr>
+          <p:cNvPr id="6" name="TextBox 5"/>
+          <p:cNvSpPr txBox="1"/>
+          <p:nvPr/>
+        </p:nvSpPr>
+        <p:spPr>
+          <a:xfrm>
+            <a:off x="11155680" y="6446520"/>
+            <a:ext cx="822960" cy="320040"/>
+          </a:xfrm>
+          <a:prstGeom prst="rect">
+            <a:avLst/>
+          </a:prstGeom>
+          <a:noFill/>
+        </p:spPr>
+        <p:txBody>
+          <a:bodyPr wrap="square" anchor="t" lIns="0" rIns="0" tIns="0" bIns="0">
+            <a:spAutoFit/>
+          </a:bodyPr>
+          <a:lstStyle/>
+          <a:p>
+            <a:pPr algn="r"/>
+            <a:r>
+              <a:rPr sz="1100" b="0" i="0">
+                <a:solidFill>
+                  <a:srgbClr val="6B7280"/>
+                </a:solidFill>
+                <a:latin typeface="Calibri"/>
+              </a:rPr>
+              <a:t>21 / 21</a:t>
+            </a:r>
+          </a:p>
+        </p:txBody>
+      </p:sp>
+      <p:sp>
+        <p:nvSpPr>
+          <p:cNvPr id="7" name="TextBox 6"/>
+          <p:cNvSpPr txBox="1"/>
+          <p:nvPr/>
+        </p:nvSpPr>
+        <p:spPr>
+          <a:xfrm>
+            <a:off x="640080" y="1600200"/>
+            <a:ext cx="10881360" cy="4572000"/>
+          </a:xfrm>
+          <a:prstGeom prst="rect">
+            <a:avLst/>
+          </a:prstGeom>
+          <a:noFill/>
+        </p:spPr>
+        <p:txBody>
+          <a:bodyPr wrap="square">
+            <a:spAutoFit/>
+          </a:bodyPr>
+          <a:lstStyle/>
+          <a:p>
+            <a:pPr>
+              <a:spcAft>
+                <a:spcPts val="1400"/>
+              </a:spcAft>
+            </a:pPr>
+            <a:r>
+              <a:rPr sz="1600">
+                <a:solidFill>
+                  <a:srgbClr val="1F2937"/>
+                </a:solidFill>
+                <a:latin typeface="Calibri"/>
+              </a:rPr>
+              <a:t>•  Service/treatment time is literature-calibrated, not derived from the dataset — the dataset has no discharge timestamp. Disclosed explicitly throughout, not blended silently into the "real data" story.</a:t>
+            </a:r>
+          </a:p>
+          <a:p>
+            <a:pPr>
+              <a:spcAft>
+                <a:spcPts val="1400"/>
+              </a:spcAft>
+            </a:pPr>
+            <a:r>
+              <a:rPr sz="1600">
+                <a:solidFill>
+                  <a:srgbClr val="1F2937"/>
+                </a:solidFill>
+                <a:latin typeface="Calibri"/>
+              </a:rPr>
+              <a:t>•  Generalizability tested across 2 of the dataset's 3 departments (one academic, one community) — both replicate the core finding, but the third department and other health systems entirely are still untested.</a:t>
+            </a:r>
+          </a:p>
+          <a:p>
+            <a:pPr>
+              <a:spcAft>
+                <a:spcPts val="1400"/>
+              </a:spcAft>
+            </a:pPr>
+            <a:r>
+              <a:rPr sz="1600">
+                <a:solidFill>
+                  <a:srgbClr val="1F2937"/>
+                </a:solidFill>
+                <a:latin typeface="Calibri"/>
+              </a:rPr>
+              <a:t>•  The exchangeability breakdown was tested with 2 surrogate architectures (gradient boosting, MLP) — both fail outside the training range, via different mechanisms. Other architecture families (e.g. a GP-as-surrogate) are untested.</a:t>
+            </a:r>
+          </a:p>
+          <a:p>
+            <a:pPr>
+              <a:spcAft>
+                <a:spcPts val="1400"/>
+              </a:spcAft>
+            </a:pPr>
+            <a:r>
+              <a:rPr sz="1600">
+                <a:solidFill>
+                  <a:srgbClr val="1F2937"/>
+                </a:solidFill>
+                <a:latin typeface="Calibri"/>
+              </a:rPr>
+              <a:t>•  Literature review (30 papers, 3 in depth) still in progress.</a:t>
+            </a:r>
+          </a:p>
+          <a:p>
+            <a:pPr>
+              <a:spcAft>
+                <a:spcPts val="1400"/>
+              </a:spcAft>
+            </a:pPr>
+            <a:r>
+              <a:rPr sz="1600">
+                <a:solidFill>
+                  <a:srgbClr val="1F2937"/>
+                </a:solidFill>
+                <a:latin typeface="Calibri"/>
+              </a:rPr>
+              <a:t>•  This is a working results deck, not the final end-sem PPT — that will follow the instructor's specific guidelines once shared.</a:t>
             </a:r>
           </a:p>
         </p:txBody>
@@ -7779,7 +11217,7 @@
                 </a:solidFill>
                 <a:latin typeface="Calibri"/>
               </a:rPr>
-              <a:t>3 / 16</a:t>
+              <a:t>3 / 21</a:t>
             </a:r>
           </a:p>
         </p:txBody>
@@ -8231,7 +11669,7 @@
                 </a:solidFill>
                 <a:latin typeface="Calibri"/>
               </a:rPr>
-              <a:t>4 / 16</a:t>
+              <a:t>4 / 21</a:t>
             </a:r>
           </a:p>
         </p:txBody>
@@ -8834,7 +12272,7 @@
                 </a:solidFill>
                 <a:latin typeface="Calibri"/>
               </a:rPr>
-              <a:t>5 / 16</a:t>
+              <a:t>5 / 21</a:t>
             </a:r>
           </a:p>
         </p:txBody>
@@ -9454,7 +12892,7 @@
                 </a:solidFill>
                 <a:latin typeface="Calibri"/>
               </a:rPr>
-              <a:t>6 / 16</a:t>
+              <a:t>6 / 21</a:t>
             </a:r>
           </a:p>
         </p:txBody>
@@ -10538,7 +13976,7 @@
                 </a:solidFill>
                 <a:latin typeface="Calibri"/>
               </a:rPr>
-              <a:t>7 / 16</a:t>
+              <a:t>7 / 21</a:t>
             </a:r>
           </a:p>
         </p:txBody>
@@ -11040,7 +14478,7 @@
                 </a:solidFill>
                 <a:latin typeface="Calibri"/>
               </a:rPr>
-              <a:t>8 / 16</a:t>
+              <a:t>8 / 21</a:t>
             </a:r>
           </a:p>
         </p:txBody>
@@ -11810,7 +15248,7 @@
                 </a:solidFill>
                 <a:latin typeface="Calibri"/>
               </a:rPr>
-              <a:t>9 / 16</a:t>
+              <a:t>9 / 21</a:t>
             </a:r>
           </a:p>
         </p:txBody>

</xml_diff>